<commit_message>
Issue #20 ABLESTACK 소스코드 RAG 범위 확장
</commit_message>
<xml_diff>
--- a/output/presentation/techflow-rag-poc-design.pptx
+++ b/output/presentation/techflow-rag-poc-design.pptx
@@ -2,22 +2,22 @@
 <file path=ppt/presentation.xml><?xml version="1.0" encoding="utf-8"?>
 <p:presentation xmlns:p="http://schemas.openxmlformats.org/presentationml/2006/main">
   <p:sldMasterIdLst>
-    <p:sldMasterId xmlns:r="http://schemas.openxmlformats.org/officeDocument/2006/relationships" id="2147483648" r:id="R2c94152568374c29"/>
+    <p:sldMasterId xmlns:r="http://schemas.openxmlformats.org/officeDocument/2006/relationships" id="2147483648" r:id="Rae74aed7dea744b3"/>
   </p:sldMasterIdLst>
   <p:notesMasterIdLst>
-    <p:notesMasterId xmlns:r="http://schemas.openxmlformats.org/officeDocument/2006/relationships" r:id="Rc93ae9929e7645e3"/>
+    <p:notesMasterId xmlns:r="http://schemas.openxmlformats.org/officeDocument/2006/relationships" r:id="R8b272f8c45db4723"/>
   </p:notesMasterIdLst>
   <p:sldIdLst>
-    <p:sldId xmlns:r="http://schemas.openxmlformats.org/officeDocument/2006/relationships" id="256" r:id="Re694a40dae6542c2"/>
-    <p:sldId xmlns:r="http://schemas.openxmlformats.org/officeDocument/2006/relationships" id="257" r:id="R4ede8be361194de3"/>
-    <p:sldId xmlns:r="http://schemas.openxmlformats.org/officeDocument/2006/relationships" id="258" r:id="Rd887829023e94876"/>
-    <p:sldId xmlns:r="http://schemas.openxmlformats.org/officeDocument/2006/relationships" id="259" r:id="R1599b56e02e2457f"/>
-    <p:sldId xmlns:r="http://schemas.openxmlformats.org/officeDocument/2006/relationships" id="260" r:id="Rcd0d351e44354e7c"/>
-    <p:sldId xmlns:r="http://schemas.openxmlformats.org/officeDocument/2006/relationships" id="261" r:id="R218107849a754045"/>
-    <p:sldId xmlns:r="http://schemas.openxmlformats.org/officeDocument/2006/relationships" id="262" r:id="Rff7757446532456f"/>
-    <p:sldId xmlns:r="http://schemas.openxmlformats.org/officeDocument/2006/relationships" id="263" r:id="R9866e6176f474fd5"/>
-    <p:sldId xmlns:r="http://schemas.openxmlformats.org/officeDocument/2006/relationships" id="264" r:id="R6833cffee5b245fc"/>
-    <p:sldId xmlns:r="http://schemas.openxmlformats.org/officeDocument/2006/relationships" id="265" r:id="Rd70efbdd1cb04058"/>
+    <p:sldId xmlns:r="http://schemas.openxmlformats.org/officeDocument/2006/relationships" id="256" r:id="R2bfaedd7a7a64c56"/>
+    <p:sldId xmlns:r="http://schemas.openxmlformats.org/officeDocument/2006/relationships" id="257" r:id="R836b0788e4af45ac"/>
+    <p:sldId xmlns:r="http://schemas.openxmlformats.org/officeDocument/2006/relationships" id="258" r:id="R199bbb7ab8aa41ef"/>
+    <p:sldId xmlns:r="http://schemas.openxmlformats.org/officeDocument/2006/relationships" id="259" r:id="R1d8259b1b60d439d"/>
+    <p:sldId xmlns:r="http://schemas.openxmlformats.org/officeDocument/2006/relationships" id="260" r:id="R197217479e4f4caa"/>
+    <p:sldId xmlns:r="http://schemas.openxmlformats.org/officeDocument/2006/relationships" id="261" r:id="R8eee312b8780451f"/>
+    <p:sldId xmlns:r="http://schemas.openxmlformats.org/officeDocument/2006/relationships" id="262" r:id="R31f74510c057477a"/>
+    <p:sldId xmlns:r="http://schemas.openxmlformats.org/officeDocument/2006/relationships" id="263" r:id="R8fbe8c7eb8ee4b6b"/>
+    <p:sldId xmlns:r="http://schemas.openxmlformats.org/officeDocument/2006/relationships" id="264" r:id="Ra3e28197686d44ea"/>
+    <p:sldId xmlns:r="http://schemas.openxmlformats.org/officeDocument/2006/relationships" id="265" r:id="Re9b451bf442c4d85"/>
   </p:sldIdLst>
   <p:sldSz cx="12192000" cy="6858000"/>
   <p:notesSz cx="6858000" cy="9144000"/>
@@ -451,7 +451,7 @@
           <a:lstStyle xmlns:a="http://schemas.openxmlformats.org/drawingml/2006/main"/>
           <a:p xmlns:a="http://schemas.openxmlformats.org/drawingml/2006/main">
             <a:r>
-              <a:t>Issue #20 RAG PoC 상세 설계 발표자료 1쪽입니다.</a:t>
+              <a:t>Issue #20 문서·소스코드 RAG PoC 개정 설계 발표자료 1쪽입니다.</a:t>
             </a:r>
           </a:p>
           <a:p xmlns:a="http://schemas.openxmlformats.org/drawingml/2006/main">
@@ -481,12 +481,42 @@
           </a:p>
           <a:p xmlns:a="http://schemas.openxmlformats.org/drawingml/2006/main">
             <a:r>
+              <a:t>- https://github.com/ablecloud-team/ablestack-cloud</a:t>
+            </a:r>
+          </a:p>
+          <a:p xmlns:a="http://schemas.openxmlformats.org/drawingml/2006/main">
+            <a:r>
+              <a:t>- https://github.com/ablecloud-team/ablestack-wall</a:t>
+            </a:r>
+          </a:p>
+          <a:p xmlns:a="http://schemas.openxmlformats.org/drawingml/2006/main">
+            <a:r>
+              <a:t>- https://github.com/ablecloud-team/ablestack-cockpit-plugin</a:t>
+            </a:r>
+          </a:p>
+          <a:p xmlns:a="http://schemas.openxmlformats.org/drawingml/2006/main">
+            <a:r>
+              <a:t>- https://github.com/ablecloud-team/ablestack-genie</a:t>
+            </a:r>
+          </a:p>
+          <a:p xmlns:a="http://schemas.openxmlformats.org/drawingml/2006/main">
+            <a:r>
+              <a:t>- https://github.com/ablecloud-team/ablestack-kickstart</a:t>
+            </a:r>
+          </a:p>
+          <a:p xmlns:a="http://schemas.openxmlformats.org/drawingml/2006/main">
+            <a:r>
+              <a:t>- https://github.com/ablecloud-team/ablestack-qemu-exec-tools</a:t>
+            </a:r>
+          </a:p>
+          <a:p xmlns:a="http://schemas.openxmlformats.org/drawingml/2006/main">
+            <a:r>
               <a:t>- https://github.com/pgvector/pgvector</a:t>
             </a:r>
           </a:p>
           <a:p xmlns:a="http://schemas.openxmlformats.org/drawingml/2006/main">
             <a:r>
-              <a:t>- https://docs.github.com/en/rest/repos/contents</a:t>
+              <a:t>- https://docs.github.com/en/rest/git/trees</a:t>
             </a:r>
           </a:p>
           <a:p xmlns:a="http://schemas.openxmlformats.org/drawingml/2006/main">
@@ -561,7 +591,7 @@
           <a:lstStyle xmlns:a="http://schemas.openxmlformats.org/drawingml/2006/main"/>
           <a:p xmlns:a="http://schemas.openxmlformats.org/drawingml/2006/main">
             <a:r>
-              <a:t>Issue #20 RAG PoC 상세 설계 발표자료 10쪽입니다.</a:t>
+              <a:t>Issue #20 문서·소스코드 RAG PoC 개정 설계 발표자료 10쪽입니다.</a:t>
             </a:r>
           </a:p>
           <a:p xmlns:a="http://schemas.openxmlformats.org/drawingml/2006/main">
@@ -591,12 +621,42 @@
           </a:p>
           <a:p xmlns:a="http://schemas.openxmlformats.org/drawingml/2006/main">
             <a:r>
+              <a:t>- https://github.com/ablecloud-team/ablestack-cloud</a:t>
+            </a:r>
+          </a:p>
+          <a:p xmlns:a="http://schemas.openxmlformats.org/drawingml/2006/main">
+            <a:r>
+              <a:t>- https://github.com/ablecloud-team/ablestack-wall</a:t>
+            </a:r>
+          </a:p>
+          <a:p xmlns:a="http://schemas.openxmlformats.org/drawingml/2006/main">
+            <a:r>
+              <a:t>- https://github.com/ablecloud-team/ablestack-cockpit-plugin</a:t>
+            </a:r>
+          </a:p>
+          <a:p xmlns:a="http://schemas.openxmlformats.org/drawingml/2006/main">
+            <a:r>
+              <a:t>- https://github.com/ablecloud-team/ablestack-genie</a:t>
+            </a:r>
+          </a:p>
+          <a:p xmlns:a="http://schemas.openxmlformats.org/drawingml/2006/main">
+            <a:r>
+              <a:t>- https://github.com/ablecloud-team/ablestack-kickstart</a:t>
+            </a:r>
+          </a:p>
+          <a:p xmlns:a="http://schemas.openxmlformats.org/drawingml/2006/main">
+            <a:r>
+              <a:t>- https://github.com/ablecloud-team/ablestack-qemu-exec-tools</a:t>
+            </a:r>
+          </a:p>
+          <a:p xmlns:a="http://schemas.openxmlformats.org/drawingml/2006/main">
+            <a:r>
               <a:t>- https://github.com/pgvector/pgvector</a:t>
             </a:r>
           </a:p>
           <a:p xmlns:a="http://schemas.openxmlformats.org/drawingml/2006/main">
             <a:r>
-              <a:t>- https://docs.github.com/en/rest/repos/contents</a:t>
+              <a:t>- https://docs.github.com/en/rest/git/trees</a:t>
             </a:r>
           </a:p>
           <a:p xmlns:a="http://schemas.openxmlformats.org/drawingml/2006/main">
@@ -671,7 +731,7 @@
           <a:lstStyle xmlns:a="http://schemas.openxmlformats.org/drawingml/2006/main"/>
           <a:p xmlns:a="http://schemas.openxmlformats.org/drawingml/2006/main">
             <a:r>
-              <a:t>Issue #20 RAG PoC 상세 설계 발표자료 2쪽입니다.</a:t>
+              <a:t>Issue #20 문서·소스코드 RAG PoC 개정 설계 발표자료 2쪽입니다.</a:t>
             </a:r>
           </a:p>
           <a:p xmlns:a="http://schemas.openxmlformats.org/drawingml/2006/main">
@@ -701,12 +761,42 @@
           </a:p>
           <a:p xmlns:a="http://schemas.openxmlformats.org/drawingml/2006/main">
             <a:r>
+              <a:t>- https://github.com/ablecloud-team/ablestack-cloud</a:t>
+            </a:r>
+          </a:p>
+          <a:p xmlns:a="http://schemas.openxmlformats.org/drawingml/2006/main">
+            <a:r>
+              <a:t>- https://github.com/ablecloud-team/ablestack-wall</a:t>
+            </a:r>
+          </a:p>
+          <a:p xmlns:a="http://schemas.openxmlformats.org/drawingml/2006/main">
+            <a:r>
+              <a:t>- https://github.com/ablecloud-team/ablestack-cockpit-plugin</a:t>
+            </a:r>
+          </a:p>
+          <a:p xmlns:a="http://schemas.openxmlformats.org/drawingml/2006/main">
+            <a:r>
+              <a:t>- https://github.com/ablecloud-team/ablestack-genie</a:t>
+            </a:r>
+          </a:p>
+          <a:p xmlns:a="http://schemas.openxmlformats.org/drawingml/2006/main">
+            <a:r>
+              <a:t>- https://github.com/ablecloud-team/ablestack-kickstart</a:t>
+            </a:r>
+          </a:p>
+          <a:p xmlns:a="http://schemas.openxmlformats.org/drawingml/2006/main">
+            <a:r>
+              <a:t>- https://github.com/ablecloud-team/ablestack-qemu-exec-tools</a:t>
+            </a:r>
+          </a:p>
+          <a:p xmlns:a="http://schemas.openxmlformats.org/drawingml/2006/main">
+            <a:r>
               <a:t>- https://github.com/pgvector/pgvector</a:t>
             </a:r>
           </a:p>
           <a:p xmlns:a="http://schemas.openxmlformats.org/drawingml/2006/main">
             <a:r>
-              <a:t>- https://docs.github.com/en/rest/repos/contents</a:t>
+              <a:t>- https://docs.github.com/en/rest/git/trees</a:t>
             </a:r>
           </a:p>
           <a:p xmlns:a="http://schemas.openxmlformats.org/drawingml/2006/main">
@@ -781,7 +871,7 @@
           <a:lstStyle xmlns:a="http://schemas.openxmlformats.org/drawingml/2006/main"/>
           <a:p xmlns:a="http://schemas.openxmlformats.org/drawingml/2006/main">
             <a:r>
-              <a:t>Issue #20 RAG PoC 상세 설계 발표자료 3쪽입니다.</a:t>
+              <a:t>Issue #20 문서·소스코드 RAG PoC 개정 설계 발표자료 3쪽입니다.</a:t>
             </a:r>
           </a:p>
           <a:p xmlns:a="http://schemas.openxmlformats.org/drawingml/2006/main">
@@ -811,12 +901,42 @@
           </a:p>
           <a:p xmlns:a="http://schemas.openxmlformats.org/drawingml/2006/main">
             <a:r>
+              <a:t>- https://github.com/ablecloud-team/ablestack-cloud</a:t>
+            </a:r>
+          </a:p>
+          <a:p xmlns:a="http://schemas.openxmlformats.org/drawingml/2006/main">
+            <a:r>
+              <a:t>- https://github.com/ablecloud-team/ablestack-wall</a:t>
+            </a:r>
+          </a:p>
+          <a:p xmlns:a="http://schemas.openxmlformats.org/drawingml/2006/main">
+            <a:r>
+              <a:t>- https://github.com/ablecloud-team/ablestack-cockpit-plugin</a:t>
+            </a:r>
+          </a:p>
+          <a:p xmlns:a="http://schemas.openxmlformats.org/drawingml/2006/main">
+            <a:r>
+              <a:t>- https://github.com/ablecloud-team/ablestack-genie</a:t>
+            </a:r>
+          </a:p>
+          <a:p xmlns:a="http://schemas.openxmlformats.org/drawingml/2006/main">
+            <a:r>
+              <a:t>- https://github.com/ablecloud-team/ablestack-kickstart</a:t>
+            </a:r>
+          </a:p>
+          <a:p xmlns:a="http://schemas.openxmlformats.org/drawingml/2006/main">
+            <a:r>
+              <a:t>- https://github.com/ablecloud-team/ablestack-qemu-exec-tools</a:t>
+            </a:r>
+          </a:p>
+          <a:p xmlns:a="http://schemas.openxmlformats.org/drawingml/2006/main">
+            <a:r>
               <a:t>- https://github.com/pgvector/pgvector</a:t>
             </a:r>
           </a:p>
           <a:p xmlns:a="http://schemas.openxmlformats.org/drawingml/2006/main">
             <a:r>
-              <a:t>- https://docs.github.com/en/rest/repos/contents</a:t>
+              <a:t>- https://docs.github.com/en/rest/git/trees</a:t>
             </a:r>
           </a:p>
           <a:p xmlns:a="http://schemas.openxmlformats.org/drawingml/2006/main">
@@ -891,7 +1011,7 @@
           <a:lstStyle xmlns:a="http://schemas.openxmlformats.org/drawingml/2006/main"/>
           <a:p xmlns:a="http://schemas.openxmlformats.org/drawingml/2006/main">
             <a:r>
-              <a:t>Issue #20 RAG PoC 상세 설계 발표자료 4쪽입니다.</a:t>
+              <a:t>Issue #20 문서·소스코드 RAG PoC 개정 설계 발표자료 4쪽입니다.</a:t>
             </a:r>
           </a:p>
           <a:p xmlns:a="http://schemas.openxmlformats.org/drawingml/2006/main">
@@ -921,12 +1041,42 @@
           </a:p>
           <a:p xmlns:a="http://schemas.openxmlformats.org/drawingml/2006/main">
             <a:r>
+              <a:t>- https://github.com/ablecloud-team/ablestack-cloud</a:t>
+            </a:r>
+          </a:p>
+          <a:p xmlns:a="http://schemas.openxmlformats.org/drawingml/2006/main">
+            <a:r>
+              <a:t>- https://github.com/ablecloud-team/ablestack-wall</a:t>
+            </a:r>
+          </a:p>
+          <a:p xmlns:a="http://schemas.openxmlformats.org/drawingml/2006/main">
+            <a:r>
+              <a:t>- https://github.com/ablecloud-team/ablestack-cockpit-plugin</a:t>
+            </a:r>
+          </a:p>
+          <a:p xmlns:a="http://schemas.openxmlformats.org/drawingml/2006/main">
+            <a:r>
+              <a:t>- https://github.com/ablecloud-team/ablestack-genie</a:t>
+            </a:r>
+          </a:p>
+          <a:p xmlns:a="http://schemas.openxmlformats.org/drawingml/2006/main">
+            <a:r>
+              <a:t>- https://github.com/ablecloud-team/ablestack-kickstart</a:t>
+            </a:r>
+          </a:p>
+          <a:p xmlns:a="http://schemas.openxmlformats.org/drawingml/2006/main">
+            <a:r>
+              <a:t>- https://github.com/ablecloud-team/ablestack-qemu-exec-tools</a:t>
+            </a:r>
+          </a:p>
+          <a:p xmlns:a="http://schemas.openxmlformats.org/drawingml/2006/main">
+            <a:r>
               <a:t>- https://github.com/pgvector/pgvector</a:t>
             </a:r>
           </a:p>
           <a:p xmlns:a="http://schemas.openxmlformats.org/drawingml/2006/main">
             <a:r>
-              <a:t>- https://docs.github.com/en/rest/repos/contents</a:t>
+              <a:t>- https://docs.github.com/en/rest/git/trees</a:t>
             </a:r>
           </a:p>
           <a:p xmlns:a="http://schemas.openxmlformats.org/drawingml/2006/main">
@@ -1001,7 +1151,7 @@
           <a:lstStyle xmlns:a="http://schemas.openxmlformats.org/drawingml/2006/main"/>
           <a:p xmlns:a="http://schemas.openxmlformats.org/drawingml/2006/main">
             <a:r>
-              <a:t>Issue #20 RAG PoC 상세 설계 발표자료 5쪽입니다.</a:t>
+              <a:t>Issue #20 문서·소스코드 RAG PoC 개정 설계 발표자료 5쪽입니다.</a:t>
             </a:r>
           </a:p>
           <a:p xmlns:a="http://schemas.openxmlformats.org/drawingml/2006/main">
@@ -1031,12 +1181,42 @@
           </a:p>
           <a:p xmlns:a="http://schemas.openxmlformats.org/drawingml/2006/main">
             <a:r>
+              <a:t>- https://github.com/ablecloud-team/ablestack-cloud</a:t>
+            </a:r>
+          </a:p>
+          <a:p xmlns:a="http://schemas.openxmlformats.org/drawingml/2006/main">
+            <a:r>
+              <a:t>- https://github.com/ablecloud-team/ablestack-wall</a:t>
+            </a:r>
+          </a:p>
+          <a:p xmlns:a="http://schemas.openxmlformats.org/drawingml/2006/main">
+            <a:r>
+              <a:t>- https://github.com/ablecloud-team/ablestack-cockpit-plugin</a:t>
+            </a:r>
+          </a:p>
+          <a:p xmlns:a="http://schemas.openxmlformats.org/drawingml/2006/main">
+            <a:r>
+              <a:t>- https://github.com/ablecloud-team/ablestack-genie</a:t>
+            </a:r>
+          </a:p>
+          <a:p xmlns:a="http://schemas.openxmlformats.org/drawingml/2006/main">
+            <a:r>
+              <a:t>- https://github.com/ablecloud-team/ablestack-kickstart</a:t>
+            </a:r>
+          </a:p>
+          <a:p xmlns:a="http://schemas.openxmlformats.org/drawingml/2006/main">
+            <a:r>
+              <a:t>- https://github.com/ablecloud-team/ablestack-qemu-exec-tools</a:t>
+            </a:r>
+          </a:p>
+          <a:p xmlns:a="http://schemas.openxmlformats.org/drawingml/2006/main">
+            <a:r>
               <a:t>- https://github.com/pgvector/pgvector</a:t>
             </a:r>
           </a:p>
           <a:p xmlns:a="http://schemas.openxmlformats.org/drawingml/2006/main">
             <a:r>
-              <a:t>- https://docs.github.com/en/rest/repos/contents</a:t>
+              <a:t>- https://docs.github.com/en/rest/git/trees</a:t>
             </a:r>
           </a:p>
           <a:p xmlns:a="http://schemas.openxmlformats.org/drawingml/2006/main">
@@ -1111,7 +1291,7 @@
           <a:lstStyle xmlns:a="http://schemas.openxmlformats.org/drawingml/2006/main"/>
           <a:p xmlns:a="http://schemas.openxmlformats.org/drawingml/2006/main">
             <a:r>
-              <a:t>Issue #20 RAG PoC 상세 설계 발표자료 6쪽입니다.</a:t>
+              <a:t>Issue #20 문서·소스코드 RAG PoC 개정 설계 발표자료 6쪽입니다.</a:t>
             </a:r>
           </a:p>
           <a:p xmlns:a="http://schemas.openxmlformats.org/drawingml/2006/main">
@@ -1141,12 +1321,42 @@
           </a:p>
           <a:p xmlns:a="http://schemas.openxmlformats.org/drawingml/2006/main">
             <a:r>
+              <a:t>- https://github.com/ablecloud-team/ablestack-cloud</a:t>
+            </a:r>
+          </a:p>
+          <a:p xmlns:a="http://schemas.openxmlformats.org/drawingml/2006/main">
+            <a:r>
+              <a:t>- https://github.com/ablecloud-team/ablestack-wall</a:t>
+            </a:r>
+          </a:p>
+          <a:p xmlns:a="http://schemas.openxmlformats.org/drawingml/2006/main">
+            <a:r>
+              <a:t>- https://github.com/ablecloud-team/ablestack-cockpit-plugin</a:t>
+            </a:r>
+          </a:p>
+          <a:p xmlns:a="http://schemas.openxmlformats.org/drawingml/2006/main">
+            <a:r>
+              <a:t>- https://github.com/ablecloud-team/ablestack-genie</a:t>
+            </a:r>
+          </a:p>
+          <a:p xmlns:a="http://schemas.openxmlformats.org/drawingml/2006/main">
+            <a:r>
+              <a:t>- https://github.com/ablecloud-team/ablestack-kickstart</a:t>
+            </a:r>
+          </a:p>
+          <a:p xmlns:a="http://schemas.openxmlformats.org/drawingml/2006/main">
+            <a:r>
+              <a:t>- https://github.com/ablecloud-team/ablestack-qemu-exec-tools</a:t>
+            </a:r>
+          </a:p>
+          <a:p xmlns:a="http://schemas.openxmlformats.org/drawingml/2006/main">
+            <a:r>
               <a:t>- https://github.com/pgvector/pgvector</a:t>
             </a:r>
           </a:p>
           <a:p xmlns:a="http://schemas.openxmlformats.org/drawingml/2006/main">
             <a:r>
-              <a:t>- https://docs.github.com/en/rest/repos/contents</a:t>
+              <a:t>- https://docs.github.com/en/rest/git/trees</a:t>
             </a:r>
           </a:p>
           <a:p xmlns:a="http://schemas.openxmlformats.org/drawingml/2006/main">
@@ -1221,7 +1431,7 @@
           <a:lstStyle xmlns:a="http://schemas.openxmlformats.org/drawingml/2006/main"/>
           <a:p xmlns:a="http://schemas.openxmlformats.org/drawingml/2006/main">
             <a:r>
-              <a:t>Issue #20 RAG PoC 상세 설계 발표자료 7쪽입니다.</a:t>
+              <a:t>Issue #20 문서·소스코드 RAG PoC 개정 설계 발표자료 7쪽입니다.</a:t>
             </a:r>
           </a:p>
           <a:p xmlns:a="http://schemas.openxmlformats.org/drawingml/2006/main">
@@ -1251,12 +1461,42 @@
           </a:p>
           <a:p xmlns:a="http://schemas.openxmlformats.org/drawingml/2006/main">
             <a:r>
+              <a:t>- https://github.com/ablecloud-team/ablestack-cloud</a:t>
+            </a:r>
+          </a:p>
+          <a:p xmlns:a="http://schemas.openxmlformats.org/drawingml/2006/main">
+            <a:r>
+              <a:t>- https://github.com/ablecloud-team/ablestack-wall</a:t>
+            </a:r>
+          </a:p>
+          <a:p xmlns:a="http://schemas.openxmlformats.org/drawingml/2006/main">
+            <a:r>
+              <a:t>- https://github.com/ablecloud-team/ablestack-cockpit-plugin</a:t>
+            </a:r>
+          </a:p>
+          <a:p xmlns:a="http://schemas.openxmlformats.org/drawingml/2006/main">
+            <a:r>
+              <a:t>- https://github.com/ablecloud-team/ablestack-genie</a:t>
+            </a:r>
+          </a:p>
+          <a:p xmlns:a="http://schemas.openxmlformats.org/drawingml/2006/main">
+            <a:r>
+              <a:t>- https://github.com/ablecloud-team/ablestack-kickstart</a:t>
+            </a:r>
+          </a:p>
+          <a:p xmlns:a="http://schemas.openxmlformats.org/drawingml/2006/main">
+            <a:r>
+              <a:t>- https://github.com/ablecloud-team/ablestack-qemu-exec-tools</a:t>
+            </a:r>
+          </a:p>
+          <a:p xmlns:a="http://schemas.openxmlformats.org/drawingml/2006/main">
+            <a:r>
               <a:t>- https://github.com/pgvector/pgvector</a:t>
             </a:r>
           </a:p>
           <a:p xmlns:a="http://schemas.openxmlformats.org/drawingml/2006/main">
             <a:r>
-              <a:t>- https://docs.github.com/en/rest/repos/contents</a:t>
+              <a:t>- https://docs.github.com/en/rest/git/trees</a:t>
             </a:r>
           </a:p>
           <a:p xmlns:a="http://schemas.openxmlformats.org/drawingml/2006/main">
@@ -1331,7 +1571,7 @@
           <a:lstStyle xmlns:a="http://schemas.openxmlformats.org/drawingml/2006/main"/>
           <a:p xmlns:a="http://schemas.openxmlformats.org/drawingml/2006/main">
             <a:r>
-              <a:t>Issue #20 RAG PoC 상세 설계 발표자료 8쪽입니다.</a:t>
+              <a:t>Issue #20 문서·소스코드 RAG PoC 개정 설계 발표자료 8쪽입니다.</a:t>
             </a:r>
           </a:p>
           <a:p xmlns:a="http://schemas.openxmlformats.org/drawingml/2006/main">
@@ -1361,12 +1601,42 @@
           </a:p>
           <a:p xmlns:a="http://schemas.openxmlformats.org/drawingml/2006/main">
             <a:r>
+              <a:t>- https://github.com/ablecloud-team/ablestack-cloud</a:t>
+            </a:r>
+          </a:p>
+          <a:p xmlns:a="http://schemas.openxmlformats.org/drawingml/2006/main">
+            <a:r>
+              <a:t>- https://github.com/ablecloud-team/ablestack-wall</a:t>
+            </a:r>
+          </a:p>
+          <a:p xmlns:a="http://schemas.openxmlformats.org/drawingml/2006/main">
+            <a:r>
+              <a:t>- https://github.com/ablecloud-team/ablestack-cockpit-plugin</a:t>
+            </a:r>
+          </a:p>
+          <a:p xmlns:a="http://schemas.openxmlformats.org/drawingml/2006/main">
+            <a:r>
+              <a:t>- https://github.com/ablecloud-team/ablestack-genie</a:t>
+            </a:r>
+          </a:p>
+          <a:p xmlns:a="http://schemas.openxmlformats.org/drawingml/2006/main">
+            <a:r>
+              <a:t>- https://github.com/ablecloud-team/ablestack-kickstart</a:t>
+            </a:r>
+          </a:p>
+          <a:p xmlns:a="http://schemas.openxmlformats.org/drawingml/2006/main">
+            <a:r>
+              <a:t>- https://github.com/ablecloud-team/ablestack-qemu-exec-tools</a:t>
+            </a:r>
+          </a:p>
+          <a:p xmlns:a="http://schemas.openxmlformats.org/drawingml/2006/main">
+            <a:r>
               <a:t>- https://github.com/pgvector/pgvector</a:t>
             </a:r>
           </a:p>
           <a:p xmlns:a="http://schemas.openxmlformats.org/drawingml/2006/main">
             <a:r>
-              <a:t>- https://docs.github.com/en/rest/repos/contents</a:t>
+              <a:t>- https://docs.github.com/en/rest/git/trees</a:t>
             </a:r>
           </a:p>
           <a:p xmlns:a="http://schemas.openxmlformats.org/drawingml/2006/main">
@@ -1441,7 +1711,7 @@
           <a:lstStyle xmlns:a="http://schemas.openxmlformats.org/drawingml/2006/main"/>
           <a:p xmlns:a="http://schemas.openxmlformats.org/drawingml/2006/main">
             <a:r>
-              <a:t>Issue #20 RAG PoC 상세 설계 발표자료 9쪽입니다.</a:t>
+              <a:t>Issue #20 문서·소스코드 RAG PoC 개정 설계 발표자료 9쪽입니다.</a:t>
             </a:r>
           </a:p>
           <a:p xmlns:a="http://schemas.openxmlformats.org/drawingml/2006/main">
@@ -1471,12 +1741,42 @@
           </a:p>
           <a:p xmlns:a="http://schemas.openxmlformats.org/drawingml/2006/main">
             <a:r>
+              <a:t>- https://github.com/ablecloud-team/ablestack-cloud</a:t>
+            </a:r>
+          </a:p>
+          <a:p xmlns:a="http://schemas.openxmlformats.org/drawingml/2006/main">
+            <a:r>
+              <a:t>- https://github.com/ablecloud-team/ablestack-wall</a:t>
+            </a:r>
+          </a:p>
+          <a:p xmlns:a="http://schemas.openxmlformats.org/drawingml/2006/main">
+            <a:r>
+              <a:t>- https://github.com/ablecloud-team/ablestack-cockpit-plugin</a:t>
+            </a:r>
+          </a:p>
+          <a:p xmlns:a="http://schemas.openxmlformats.org/drawingml/2006/main">
+            <a:r>
+              <a:t>- https://github.com/ablecloud-team/ablestack-genie</a:t>
+            </a:r>
+          </a:p>
+          <a:p xmlns:a="http://schemas.openxmlformats.org/drawingml/2006/main">
+            <a:r>
+              <a:t>- https://github.com/ablecloud-team/ablestack-kickstart</a:t>
+            </a:r>
+          </a:p>
+          <a:p xmlns:a="http://schemas.openxmlformats.org/drawingml/2006/main">
+            <a:r>
+              <a:t>- https://github.com/ablecloud-team/ablestack-qemu-exec-tools</a:t>
+            </a:r>
+          </a:p>
+          <a:p xmlns:a="http://schemas.openxmlformats.org/drawingml/2006/main">
+            <a:r>
               <a:t>- https://github.com/pgvector/pgvector</a:t>
             </a:r>
           </a:p>
           <a:p xmlns:a="http://schemas.openxmlformats.org/drawingml/2006/main">
             <a:r>
-              <a:t>- https://docs.github.com/en/rest/repos/contents</a:t>
+              <a:t>- https://docs.github.com/en/rest/git/trees</a:t>
             </a:r>
           </a:p>
           <a:p xmlns:a="http://schemas.openxmlformats.org/drawingml/2006/main">
@@ -1549,7 +1849,7 @@
   </p:cSld>
   <p:clrMap bg1="lt1" tx1="dk1" bg2="lt2" tx2="dk2" accent1="accent1" accent2="accent2" accent3="accent3" accent4="accent4" accent5="accent5" accent6="accent6" hlink="hlink" folHlink="folHlink"/>
   <p:sldLayoutIdLst>
-    <p:sldLayoutId xmlns:r="http://schemas.openxmlformats.org/officeDocument/2006/relationships" id="2147483649" r:id="R0a004b0feb8f4102"/>
+    <p:sldLayoutId xmlns:r="http://schemas.openxmlformats.org/officeDocument/2006/relationships" id="2147483649" r:id="Rf277b2bf52404aae"/>
   </p:sldLayoutIdLst>
   <p:txStyles>
     <p:titleStyle>
@@ -2129,7 +2429,7 @@
               </a:defRPr>
             </a:pPr>
             <a:r>
-              <a:t>ABLESTACK TECHFLOW · ISSUE #20</a:t>
+              <a:t>ABLESTACK TECHFLOW · ISSUE #20 · REVISED</a:t>
             </a:r>
           </a:p>
         </p:txBody>
@@ -2175,7 +2475,7 @@
               </a:defRPr>
             </a:pPr>
             <a:r>
-              <a:t>D0 공개 문서 RAG PoC</a:t>
+              <a:t>문서와 소스코드를 함께 쓰는</a:t>
             </a:r>
           </a:p>
           <a:p xmlns:a="http://schemas.openxmlformats.org/drawingml/2006/main">
@@ -2191,7 +2491,7 @@
               </a:defRPr>
             </a:pPr>
             <a:r>
-              <a:t>상세 설계와 작업 분해</a:t>
+              <a:t>RAG PoC 개정 설계</a:t>
             </a:r>
           </a:p>
         </p:txBody>
@@ -2237,7 +2537,7 @@
               </a:defRPr>
             </a:pPr>
             <a:r>
-              <a:t>Source 승인 → Hybrid Retrieval → 근거 답변 → 삭제 검증</a:t>
+              <a:t>Docs + 6 Source Repositories · 9 Profiles · No Code Execution</a:t>
             </a:r>
           </a:p>
         </p:txBody>
@@ -2378,7 +2678,7 @@
               </a:defRPr>
             </a:pPr>
             <a:r>
-              <a:t>승인 요청</a:t>
+              <a:t>개정 승인 요청</a:t>
             </a:r>
           </a:p>
         </p:txBody>
@@ -2424,7 +2724,7 @@
               </a:defRPr>
             </a:pPr>
             <a:r>
-              <a:t>Issue #20 설계를 승인하면</a:t>
+              <a:t>7개 저장소·9개 Profile을 승인하면</a:t>
             </a:r>
           </a:p>
           <a:p xmlns:a="http://schemas.openxmlformats.org/drawingml/2006/main">
@@ -2499,7 +2799,7 @@
         </p:spPr>
         <p:txBody>
           <a:bodyPr xmlns:a="http://schemas.openxmlformats.org/drawingml/2006/main" lIns="0" tIns="0" rIns="0" bIns="0" anchor="t">
-            <a:normAutofit fontScale="100000"/>
+            <a:normAutofit fontScale="82766"/>
           </a:bodyPr>
           <a:lstStyle xmlns:a="http://schemas.openxmlformats.org/drawingml/2006/main"/>
           <a:p xmlns:a="http://schemas.openxmlformats.org/drawingml/2006/main">
@@ -2515,7 +2815,7 @@
               </a:defRPr>
             </a:pPr>
             <a:r>
-              <a:t>ISSUE #20</a:t>
+              <a:t>ISSUE #20 · REVISED</a:t>
             </a:r>
           </a:p>
         </p:txBody>
@@ -2561,7 +2861,7 @@
               </a:defRPr>
             </a:pPr>
             <a:r>
-              <a:t>D0 ONLY · 276 DOCS · 10 APIs · 10 TABLES · 6 WORK ITEMS</a:t>
+              <a:t>9 PROFILES · 39,836 FILES · COMPATIBILITY GATE · NO CODE EXECUTION</a:t>
             </a:r>
           </a:p>
         </p:txBody>
@@ -2634,7 +2934,7 @@
               </a:defRPr>
             </a:pPr>
             <a:r>
-              <a:t>ABLESTACK TechFlow · RAG PoC Design Gate</a:t>
+              <a:t>ABLESTACK TechFlow · Documentation &amp; Source Code RAG Gate</a:t>
             </a:r>
           </a:p>
         </p:txBody>
@@ -2732,7 +3032,7 @@
         </p:spPr>
         <p:txBody>
           <a:bodyPr xmlns:a="http://schemas.openxmlformats.org/drawingml/2006/main" lIns="0" tIns="0" rIns="0" bIns="0" anchor="t">
-            <a:normAutofit fontScale="97842"/>
+            <a:normAutofit fontScale="89519"/>
           </a:bodyPr>
           <a:lstStyle xmlns:a="http://schemas.openxmlformats.org/drawingml/2006/main"/>
           <a:p xmlns:a="http://schemas.openxmlformats.org/drawingml/2006/main">
@@ -2748,7 +3048,7 @@
               </a:defRPr>
             </a:pPr>
             <a:r>
-              <a:t>결과: 구현 가능한 RAG 경계와 여섯 개 작업 단위를 확정했습니다</a:t>
+              <a:t>ABLESTACK 7개 저장소의 39,836개 파일을 분석 대상으로 확정했습니다</a:t>
             </a:r>
           </a:p>
         </p:txBody>
@@ -2840,7 +3140,7 @@
               </a:defRPr>
             </a:pPr>
             <a:r>
-              <a:t>공개 ABLESTACK 문서만 수집하고 근거 없는 답변과 직접 실행을 차단합니다.</a:t>
+              <a:t>Cloud 세 Branch와 5개 구성 저장소를 독립 색인하고 승인 조합만 검색합니다.</a:t>
             </a:r>
           </a:p>
         </p:txBody>
@@ -2915,7 +3215,7 @@
               </a:defRPr>
             </a:pPr>
             <a:r>
-              <a:t>초기 지식</a:t>
+              <a:t>공식 문서</a:t>
             </a:r>
           </a:p>
         </p:txBody>
@@ -2977,7 +3277,7 @@
               </a:defRPr>
             </a:pPr>
             <a:r>
-              <a:t>1 Public Repo</a:t>
+              <a:t>SHARED_DOCS</a:t>
             </a:r>
           </a:p>
           <a:p xmlns:a="http://schemas.openxmlformats.org/drawingml/2006/main">
@@ -2993,7 +3293,7 @@
               </a:defRPr>
             </a:pPr>
             <a:r>
-              <a:t>D0 Only</a:t>
+              <a:t>D0 Public</a:t>
             </a:r>
           </a:p>
         </p:txBody>
@@ -3068,7 +3368,7 @@
               </a:defRPr>
             </a:pPr>
             <a:r>
-              <a:t>제품 계약</a:t>
+              <a:t>제품 소스코드</a:t>
             </a:r>
           </a:p>
         </p:txBody>
@@ -3114,7 +3414,7 @@
               </a:defRPr>
             </a:pPr>
             <a:r>
-              <a:t>10 APIs</a:t>
+              <a:t>6 Repositories</a:t>
             </a:r>
           </a:p>
           <a:p xmlns:a="http://schemas.openxmlformats.org/drawingml/2006/main">
@@ -3130,7 +3430,7 @@
               </a:defRPr>
             </a:pPr>
             <a:r>
-              <a:t>10 Tables</a:t>
+              <a:t>8 Code Profiles</a:t>
             </a:r>
           </a:p>
           <a:p xmlns:a="http://schemas.openxmlformats.org/drawingml/2006/main">
@@ -3146,7 +3446,7 @@
               </a:defRPr>
             </a:pPr>
             <a:r>
-              <a:t>3 Answer States</a:t>
+              <a:t>39,560 Files</a:t>
             </a:r>
           </a:p>
         </p:txBody>
@@ -3221,7 +3521,7 @@
               </a:defRPr>
             </a:pPr>
             <a:r>
-              <a:t>작업 분해</a:t>
+              <a:t>개정 범위</a:t>
             </a:r>
           </a:p>
         </p:txBody>
@@ -3267,7 +3567,7 @@
               </a:defRPr>
             </a:pPr>
             <a:r>
-              <a:t>6 Issues  |  #41 → #46  |  Design Approval Pending</a:t>
+              <a:t>9 Profiles  |  39,836 Files  |  14 Tables  |  50 Golden Questions</a:t>
             </a:r>
           </a:p>
         </p:txBody>
@@ -3335,7 +3635,7 @@
               </a:defRPr>
             </a:pPr>
             <a:r>
-              <a:t>실행·정책·저장을 세 계층으로 분리했습니다</a:t>
+              <a:t>실행·분석·저장을 분리해 소스코드를 안전하게 다룹니다</a:t>
             </a:r>
           </a:p>
         </p:txBody>
@@ -3427,7 +3727,7 @@
               </a:defRPr>
             </a:pPr>
             <a:r>
-              <a:t>Activepieces는 오케스트레이션하고 AI Gateway가 RAG 정책과 상태를 소유합니다.</a:t>
+              <a:t>Activepieces는 오케스트레이션하고 Fetcher·AI Gateway가 고정 Commit을 정적으로 분석합니다.</a:t>
             </a:r>
           </a:p>
         </p:txBody>
@@ -3610,7 +3910,7 @@
               </a:defRPr>
             </a:pPr>
             <a:r>
-              <a:t>Approval Flow</a:t>
+              <a:t>Approval · Job</a:t>
             </a:r>
           </a:p>
           <a:p xmlns:a="http://schemas.openxmlformats.org/drawingml/2006/main">
@@ -3793,7 +4093,7 @@
               </a:defRPr>
             </a:pPr>
             <a:r>
-              <a:t>Source Registry</a:t>
+              <a:t>Pinned Fetcher</a:t>
             </a:r>
           </a:p>
           <a:p xmlns:a="http://schemas.openxmlformats.org/drawingml/2006/main">
@@ -3809,7 +4109,7 @@
               </a:defRPr>
             </a:pPr>
             <a:r>
-              <a:t>Retrieval · Answer</a:t>
+              <a:t>Parser · Retrieval</a:t>
             </a:r>
           </a:p>
           <a:p xmlns:a="http://schemas.openxmlformats.org/drawingml/2006/main">
@@ -3825,7 +4125,7 @@
               </a:defRPr>
             </a:pPr>
             <a:r>
-              <a:t>Deletion Policy</a:t>
+              <a:t>Branch Policy</a:t>
             </a:r>
           </a:p>
         </p:txBody>
@@ -3992,7 +4292,7 @@
               </a:defRPr>
             </a:pPr>
             <a:r>
-              <a:t>Dedicated DB</a:t>
+              <a:t>FTS · pg_trgm</a:t>
             </a:r>
           </a:p>
           <a:p xmlns:a="http://schemas.openxmlformats.org/drawingml/2006/main">
@@ -4008,7 +4308,7 @@
               </a:defRPr>
             </a:pPr>
             <a:r>
-              <a:t>FTS + pgvector</a:t>
+              <a:t>pgvector</a:t>
             </a:r>
           </a:p>
           <a:p xmlns:a="http://schemas.openxmlformats.org/drawingml/2006/main">
@@ -4024,7 +4324,7 @@
               </a:defRPr>
             </a:pPr>
             <a:r>
-              <a:t>Lineage Ledger</a:t>
+              <a:t>Symbol · Lineage</a:t>
             </a:r>
           </a:p>
         </p:txBody>
@@ -4070,7 +4370,7 @@
               </a:defRPr>
             </a:pPr>
             <a:r>
-              <a:t>제품 Gate  |  Flow 실행 성공 ≠ RAG 품질 성공</a:t>
+              <a:t>제품 Gate  |  Branch 격리 · Hook/Build/Test 실행 금지 · Citation 검증</a:t>
             </a:r>
           </a:p>
         </p:txBody>
@@ -4138,7 +4438,7 @@
               </a:defRPr>
             </a:pPr>
             <a:r>
-              <a:t>Source·검색·답변·삭제 계약을 기계 검증 가능하게 고정했습니다</a:t>
+              <a:t>저장소와 코드는 서로 다른 분석 Profile을 사용합니다</a:t>
             </a:r>
           </a:p>
         </p:txBody>
@@ -4230,7 +4530,7 @@
               </a:defRPr>
             </a:pPr>
             <a:r>
-              <a:t>D0만 허용하고 ANSWERED에는 Commit·Path·Chunk 근거를 필수로 포함합니다.</a:t>
+              <a:t>코드는 Symbol·Line Range를 보존하고 Test만으로 답변하지 않습니다.</a:t>
             </a:r>
           </a:p>
         </p:txBody>
@@ -4262,7 +4562,7 @@
                     <a:lstStyle/>
                     <a:p>
                       <a:r>
-                        <a:t>계약 영역</a:t>
+                        <a:t>Source / Profile</a:t>
                       </a:r>
                     </a:p>
                   </a:txBody>
@@ -4274,7 +4574,7 @@
                     <a:lstStyle/>
                     <a:p>
                       <a:r>
-                        <a:t>결정</a:t>
+                        <a:t>분석 방식</a:t>
                       </a:r>
                     </a:p>
                   </a:txBody>
@@ -4312,7 +4612,7 @@
                     <a:lstStyle/>
                     <a:p>
                       <a:r>
-                        <a:t>Source</a:t>
+                        <a:t>SHARED_DOCS</a:t>
                       </a:r>
                     </a:p>
                   </a:txBody>
@@ -4324,7 +4624,7 @@
                     <a:lstStyle/>
                     <a:p>
                       <a:r>
-                        <a:t>공개 공식 문서</a:t>
+                        <a:t>Heading-aware</a:t>
                       </a:r>
                     </a:p>
                   </a:txBody>
@@ -4336,7 +4636,7 @@
                     <a:lstStyle/>
                     <a:p>
                       <a:r>
-                        <a:t>276 Markdown</a:t>
+                        <a:t>276 files</a:t>
                       </a:r>
                     </a:p>
                   </a:txBody>
@@ -4348,7 +4648,7 @@
                     <a:lstStyle/>
                     <a:p>
                       <a:r>
-                        <a:t>D0 승인</a:t>
+                        <a:t>D0 · Citation</a:t>
                       </a:r>
                     </a:p>
                   </a:txBody>
@@ -4362,7 +4662,7 @@
                     <a:lstStyle/>
                     <a:p>
                       <a:r>
-                        <a:t>Chunk</a:t>
+                        <a:t>CLOUD_MAIN</a:t>
                       </a:r>
                     </a:p>
                   </a:txBody>
@@ -4374,7 +4674,7 @@
                     <a:lstStyle/>
                     <a:p>
                       <a:r>
-                        <a:t>토큰 기반</a:t>
+                        <a:t>Symbol-aware</a:t>
                       </a:r>
                     </a:p>
                   </a:txBody>
@@ -4386,7 +4686,7 @@
                     <a:lstStyle/>
                     <a:p>
                       <a:r>
-                        <a:t>700 / overlap 100</a:t>
+                        <a:t>10,502 files</a:t>
                       </a:r>
                     </a:p>
                   </a:txBody>
@@ -4398,7 +4698,7 @@
                     <a:lstStyle/>
                     <a:p>
                       <a:r>
-                        <a:t>Lineage 보존</a:t>
+                        <a:t>Branch isolated</a:t>
                       </a:r>
                     </a:p>
                   </a:txBody>
@@ -4412,7 +4712,7 @@
                     <a:lstStyle/>
                     <a:p>
                       <a:r>
-                        <a:t>Lexical</a:t>
+                        <a:t>CLOUD_DIPLO</a:t>
                       </a:r>
                     </a:p>
                   </a:txBody>
@@ -4424,7 +4724,7 @@
                     <a:lstStyle/>
                     <a:p>
                       <a:r>
-                        <a:t>PostgreSQL FTS</a:t>
+                        <a:t>Symbol-aware</a:t>
                       </a:r>
                     </a:p>
                   </a:txBody>
@@ -4436,7 +4736,7 @@
                     <a:lstStyle/>
                     <a:p>
                       <a:r>
-                        <a:t>candidate 20</a:t>
+                        <a:t>10,551 files</a:t>
                       </a:r>
                     </a:p>
                   </a:txBody>
@@ -4448,7 +4748,7 @@
                     <a:lstStyle/>
                     <a:p>
                       <a:r>
-                        <a:t>제품 필터</a:t>
+                        <a:t>Branch isolated</a:t>
                       </a:r>
                     </a:p>
                   </a:txBody>
@@ -4462,7 +4762,7 @@
                     <a:lstStyle/>
                     <a:p>
                       <a:r>
-                        <a:t>Vector</a:t>
+                        <a:t>CLOUD_EUROPA</a:t>
                       </a:r>
                     </a:p>
                   </a:txBody>
@@ -4474,7 +4774,7 @@
                     <a:lstStyle/>
                     <a:p>
                       <a:r>
-                        <a:t>exact cosine</a:t>
+                        <a:t>Symbol-aware</a:t>
                       </a:r>
                     </a:p>
                   </a:txBody>
@@ -4486,7 +4786,7 @@
                     <a:lstStyle/>
                     <a:p>
                       <a:r>
-                        <a:t>candidate 20</a:t>
+                        <a:t>11,447 files</a:t>
                       </a:r>
                     </a:p>
                   </a:txBody>
@@ -4498,7 +4798,7 @@
                     <a:lstStyle/>
                     <a:p>
                       <a:r>
-                        <a:t>dimension 일치</a:t>
+                        <a:t>Branch isolated</a:t>
                       </a:r>
                     </a:p>
                   </a:txBody>
@@ -4512,7 +4812,7 @@
                     <a:lstStyle/>
                     <a:p>
                       <a:r>
-                        <a:t>Fusion</a:t>
+                        <a:t>5 COMPONENTS</a:t>
                       </a:r>
                     </a:p>
                   </a:txBody>
@@ -4524,7 +4824,7 @@
                     <a:lstStyle/>
                     <a:p>
                       <a:r>
-                        <a:t>RRF</a:t>
+                        <a:t>Repo-specific</a:t>
                       </a:r>
                     </a:p>
                   </a:txBody>
@@ -4536,7 +4836,7 @@
                     <a:lstStyle/>
                     <a:p>
                       <a:r>
-                        <a:t>k=60 / top 8</a:t>
+                        <a:t>7,060 files</a:t>
                       </a:r>
                     </a:p>
                   </a:txBody>
@@ -4548,7 +4848,7 @@
                     <a:lstStyle/>
                     <a:p>
                       <a:r>
-                        <a:t>source당 최대 3</a:t>
+                        <a:t>Compatibility gate</a:t>
                       </a:r>
                     </a:p>
                   </a:txBody>
@@ -4562,7 +4862,7 @@
                     <a:lstStyle/>
                     <a:p>
                       <a:r>
-                        <a:t>Answer</a:t>
+                        <a:t>TEST_CODE</a:t>
                       </a:r>
                     </a:p>
                   </a:txBody>
@@ -4574,7 +4874,7 @@
                     <a:lstStyle/>
                     <a:p>
                       <a:r>
-                        <a:t>근거 필수</a:t>
+                        <a:t>Corroborative</a:t>
                       </a:r>
                     </a:p>
                   </a:txBody>
@@ -4586,7 +4886,7 @@
                     <a:lstStyle/>
                     <a:p>
                       <a:r>
-                        <a:t>3 states</a:t>
+                        <a:t>weight 0.6</a:t>
                       </a:r>
                     </a:p>
                   </a:txBody>
@@ -4598,7 +4898,7 @@
                     <a:lstStyle/>
                     <a:p>
                       <a:r>
-                        <a:t>Citation 검증</a:t>
+                        <a:t>단독 답변 금지</a:t>
                       </a:r>
                     </a:p>
                   </a:txBody>
@@ -4612,7 +4912,7 @@
                     <a:lstStyle/>
                     <a:p>
                       <a:r>
-                        <a:t>Deletion</a:t>
+                        <a:t>Retrieval</a:t>
                       </a:r>
                     </a:p>
                   </a:txBody>
@@ -4624,7 +4924,7 @@
                     <a:lstStyle/>
                     <a:p>
                       <a:r>
-                        <a:t>즉시 검색 제외</a:t>
+                        <a:t>FTS + ID + Vector</a:t>
                       </a:r>
                     </a:p>
                   </a:txBody>
@@ -4636,7 +4936,7 @@
                     <a:lstStyle/>
                     <a:p>
                       <a:r>
-                        <a:t>SLO ≤ 7d</a:t>
+                        <a:t>20 + 20 + 30</a:t>
                       </a:r>
                     </a:p>
                   </a:txBody>
@@ -4648,7 +4948,7 @@
                     <a:lstStyle/>
                     <a:p>
                       <a:r>
-                        <a:t>Lineage 0건</a:t>
+                        <a:t>RRF · top 10</a:t>
                       </a:r>
                     </a:p>
                   </a:txBody>
@@ -4662,7 +4962,7 @@
                     <a:lstStyle/>
                     <a:p>
                       <a:r>
-                        <a:t>Agency</a:t>
+                        <a:t>Citation / Safety</a:t>
                       </a:r>
                     </a:p>
                   </a:txBody>
@@ -4674,7 +4974,7 @@
                     <a:lstStyle/>
                     <a:p>
                       <a:r>
-                        <a:t>직접 실행 금지</a:t>
+                        <a:t>Commit + Line</a:t>
                       </a:r>
                     </a:p>
                   </a:txBody>
@@ -4686,7 +4986,7 @@
                     <a:lstStyle/>
                     <a:p>
                       <a:r>
-                        <a:t>Tool 0</a:t>
+                        <a:t>100% resolvable</a:t>
                       </a:r>
                     </a:p>
                   </a:txBody>
@@ -4698,7 +4998,7 @@
                     <a:lstStyle/>
                     <a:p>
                       <a:r>
-                        <a:t>정책 테스트</a:t>
+                        <a:t>No execution</a:t>
                       </a:r>
                     </a:p>
                   </a:txBody>
@@ -4750,7 +5050,7 @@
               </a:defRPr>
             </a:pPr>
             <a:r>
-              <a:t>초기 HNSW는 사용하지 않고 exact cosine과 PostgreSQL FTS를 RRF로 결합합니다.</a:t>
+              <a:t>Retrieval 전에 Source Profile·Compatibility Set·Branch·Commit을 적용합니다.</a:t>
             </a:r>
           </a:p>
         </p:txBody>
@@ -4818,7 +5118,7 @@
               </a:defRPr>
             </a:pPr>
             <a:r>
-              <a:t>지식은 등록부터 삭제까지 여섯 Gate를 통과합니다</a:t>
+              <a:t>Source는 등록부터 삭제까지 여섯 Gate를 통과합니다</a:t>
             </a:r>
           </a:p>
         </p:txBody>
@@ -4910,7 +5210,7 @@
               </a:defRPr>
             </a:pPr>
             <a:r>
-              <a:t>각 단계는 Source Version·Hash·상태와 증적을 남깁니다.</a:t>
+              <a:t>새 Branch Head는 후보일 뿐이며 승인·전체 색인 성공 전에는 활성화하지 않습니다.</a:t>
             </a:r>
           </a:p>
         </p:txBody>
@@ -5123,7 +5423,7 @@
               </a:defRPr>
             </a:pPr>
             <a:r>
-              <a:t>D0 Allowlist</a:t>
+              <a:t>9 Profiles</a:t>
             </a:r>
           </a:p>
         </p:txBody>
@@ -5244,7 +5544,7 @@
               </a:defRPr>
             </a:pPr>
             <a:r>
-              <a:t>Quarantine</a:t>
+              <a:t>Pin</a:t>
             </a:r>
           </a:p>
         </p:txBody>
@@ -5290,7 +5590,7 @@
               </a:defRPr>
             </a:pPr>
             <a:r>
-              <a:t>AI Gateway</a:t>
+              <a:t>Reviewer</a:t>
             </a:r>
           </a:p>
         </p:txBody>
@@ -5336,7 +5636,7 @@
               </a:defRPr>
             </a:pPr>
             <a:r>
-              <a:t>Secret · PII Scan</a:t>
+              <a:t>Branch · Commit</a:t>
             </a:r>
           </a:p>
         </p:txBody>
@@ -5457,7 +5757,7 @@
               </a:defRPr>
             </a:pPr>
             <a:r>
-              <a:t>Approve</a:t>
+              <a:t>Quarantine</a:t>
             </a:r>
           </a:p>
         </p:txBody>
@@ -5503,7 +5803,7 @@
               </a:defRPr>
             </a:pPr>
             <a:r>
-              <a:t>Reviewer</a:t>
+              <a:t>Fetcher</a:t>
             </a:r>
           </a:p>
         </p:txBody>
@@ -5549,7 +5849,7 @@
               </a:defRPr>
             </a:pPr>
             <a:r>
-              <a:t>Version + Hash</a:t>
+              <a:t>Secret · Binary</a:t>
             </a:r>
           </a:p>
         </p:txBody>
@@ -5670,7 +5970,7 @@
               </a:defRPr>
             </a:pPr>
             <a:r>
-              <a:t>Index</a:t>
+              <a:t>Parse</a:t>
             </a:r>
           </a:p>
         </p:txBody>
@@ -5716,7 +6016,7 @@
               </a:defRPr>
             </a:pPr>
             <a:r>
-              <a:t>Worker</a:t>
+              <a:t>AI Gateway</a:t>
             </a:r>
           </a:p>
         </p:txBody>
@@ -5762,7 +6062,7 @@
               </a:defRPr>
             </a:pPr>
             <a:r>
-              <a:t>Chunk + Embed</a:t>
+              <a:t>Symbol · Fallback</a:t>
             </a:r>
           </a:p>
         </p:txBody>
@@ -5883,7 +6183,7 @@
               </a:defRPr>
             </a:pPr>
             <a:r>
-              <a:t>Answer</a:t>
+              <a:t>Index</a:t>
             </a:r>
           </a:p>
         </p:txBody>
@@ -5929,7 +6229,7 @@
               </a:defRPr>
             </a:pPr>
             <a:r>
-              <a:t>AI Gateway</a:t>
+              <a:t>Worker</a:t>
             </a:r>
           </a:p>
         </p:txBody>
@@ -5975,7 +6275,7 @@
               </a:defRPr>
             </a:pPr>
             <a:r>
-              <a:t>Citation Required</a:t>
+              <a:t>FTS · ID · Vector</a:t>
             </a:r>
           </a:p>
         </p:txBody>
@@ -6256,7 +6556,7 @@
               </a:defRPr>
             </a:pPr>
             <a:r>
-              <a:t>질문부터 답변까지 신뢰 경계를 명시했습니다</a:t>
+              <a:t>Profile과 호환 조합이 선택된 질문만 코드 답변으로 이어집니다</a:t>
             </a:r>
           </a:p>
         </p:txBody>
@@ -6348,7 +6648,7 @@
               </a:defRPr>
             </a:pPr>
             <a:r>
-              <a:t>외부 문서는 지시가 아니라 데이터이며 AI 출력은 어떤 Tool도 직접 실행하지 않습니다.</a:t>
+              <a:t>Cloud Branch나 저장소 조합이 충돌하면 임의 선택하지 않고 보류합니다.</a:t>
             </a:r>
           </a:p>
         </p:txBody>
@@ -6577,7 +6877,7 @@
               </a:defRPr>
             </a:pPr>
             <a:r>
-              <a:t>Question Event</a:t>
+              <a:t>Question</a:t>
             </a:r>
           </a:p>
           <a:p xmlns:a="http://schemas.openxmlformats.org/drawingml/2006/main">
@@ -6593,7 +6893,7 @@
               </a:defRPr>
             </a:pPr>
             <a:r>
-              <a:t>Correlation ID</a:t>
+              <a:t>Source Profiles</a:t>
             </a:r>
           </a:p>
         </p:txBody>
@@ -6714,7 +7014,7 @@
               </a:defRPr>
             </a:pPr>
             <a:r>
-              <a:t>Policy · Retrieval</a:t>
+              <a:t>Compatibility Gate</a:t>
             </a:r>
           </a:p>
           <a:p xmlns:a="http://schemas.openxmlformats.org/drawingml/2006/main">
@@ -6730,7 +7030,7 @@
               </a:defRPr>
             </a:pPr>
             <a:r>
-              <a:t>Answer State</a:t>
+              <a:t>RRF · Citation</a:t>
             </a:r>
           </a:p>
         </p:txBody>
@@ -6851,7 +7151,7 @@
               </a:defRPr>
             </a:pPr>
             <a:r>
-              <a:t>Registry · FTS</a:t>
+              <a:t>Docs · Symbols</a:t>
             </a:r>
           </a:p>
           <a:p xmlns:a="http://schemas.openxmlformats.org/drawingml/2006/main">
@@ -6867,7 +7167,7 @@
               </a:defRPr>
             </a:pPr>
             <a:r>
-              <a:t>Vector · Lineage</a:t>
+              <a:t>FTS · Vector</a:t>
             </a:r>
           </a:p>
         </p:txBody>
@@ -7004,7 +7304,7 @@
               </a:defRPr>
             </a:pPr>
             <a:r>
-              <a:t>No Training / Retention</a:t>
+              <a:t>No Tool / Training</a:t>
             </a:r>
           </a:p>
         </p:txBody>
@@ -7125,7 +7425,7 @@
               </a:defRPr>
             </a:pPr>
             <a:r>
-              <a:t>Citations</a:t>
+              <a:t>Line Citations</a:t>
             </a:r>
           </a:p>
         </p:txBody>
@@ -7269,7 +7569,7 @@
         </p:spPr>
         <p:txBody>
           <a:bodyPr xmlns:a="http://schemas.openxmlformats.org/drawingml/2006/main" lIns="0" tIns="0" rIns="0" bIns="0" anchor="t">
-            <a:normAutofit fontScale="100000"/>
+            <a:normAutofit fontScale="98942"/>
           </a:bodyPr>
           <a:lstStyle xmlns:a="http://schemas.openxmlformats.org/drawingml/2006/main"/>
           <a:p xmlns:a="http://schemas.openxmlformats.org/drawingml/2006/main">
@@ -7285,7 +7585,7 @@
               </a:defRPr>
             </a:pPr>
             <a:r>
-              <a:t>품질·보안·운영 Gate를 하나의 검증 단계로 묶었습니다</a:t>
+              <a:t>Branch·저장소 격리와 코드 Citation을 품질 Gate로 추가했습니다</a:t>
             </a:r>
           </a:p>
         </p:txBody>
@@ -7390,7 +7690,7 @@
         </p:spPr>
         <p:txBody>
           <a:bodyPr xmlns:a="http://schemas.openxmlformats.org/drawingml/2006/main" lIns="0" tIns="0" rIns="0" bIns="0" anchor="t">
-            <a:normAutofit fontScale="66927"/>
+            <a:normAutofit fontScale="71739"/>
           </a:bodyPr>
           <a:lstStyle xmlns:a="http://schemas.openxmlformats.org/drawingml/2006/main"/>
           <a:p xmlns:a="http://schemas.openxmlformats.org/drawingml/2006/main">
@@ -7406,7 +7706,7 @@
               </a:defRPr>
             </a:pPr>
             <a:r>
-              <a:t>Quality</a:t>
+              <a:t>Search</a:t>
             </a:r>
           </a:p>
         </p:txBody>
@@ -7452,7 +7752,7 @@
               </a:defRPr>
             </a:pPr>
             <a:r>
-              <a:t>Retrieval</a:t>
+              <a:t>Profile Gate</a:t>
             </a:r>
           </a:p>
         </p:txBody>
@@ -7498,7 +7798,7 @@
               </a:defRPr>
             </a:pPr>
             <a:r>
-              <a:t>Recall@8</a:t>
+              <a:t>FTS + Identifier</a:t>
             </a:r>
           </a:p>
           <a:p xmlns:a="http://schemas.openxmlformats.org/drawingml/2006/main">
@@ -7514,7 +7814,7 @@
               </a:defRPr>
             </a:pPr>
             <a:r>
-              <a:t>MRR@8</a:t>
+              <a:t>Exact Vector</a:t>
             </a:r>
           </a:p>
           <a:p xmlns:a="http://schemas.openxmlformats.org/drawingml/2006/main">
@@ -7530,7 +7830,7 @@
               </a:defRPr>
             </a:pPr>
             <a:r>
-              <a:t>Citation Precision</a:t>
+              <a:t>Cross-Branch 0</a:t>
             </a:r>
           </a:p>
         </p:txBody>
@@ -7589,7 +7889,7 @@
         </p:spPr>
         <p:txBody>
           <a:bodyPr xmlns:a="http://schemas.openxmlformats.org/drawingml/2006/main" lIns="0" tIns="0" rIns="0" bIns="0" anchor="t">
-            <a:normAutofit fontScale="77801"/>
+            <a:normAutofit fontScale="60935"/>
           </a:bodyPr>
           <a:lstStyle xmlns:a="http://schemas.openxmlformats.org/drawingml/2006/main"/>
           <a:p xmlns:a="http://schemas.openxmlformats.org/drawingml/2006/main">
@@ -7605,7 +7905,7 @@
               </a:defRPr>
             </a:pPr>
             <a:r>
-              <a:t>Safety</a:t>
+              <a:t>Citation</a:t>
             </a:r>
           </a:p>
         </p:txBody>
@@ -7651,7 +7951,7 @@
               </a:defRPr>
             </a:pPr>
             <a:r>
-              <a:t>Policy</a:t>
+              <a:t>Code Lines</a:t>
             </a:r>
           </a:p>
         </p:txBody>
@@ -7697,7 +7997,7 @@
               </a:defRPr>
             </a:pPr>
             <a:r>
-              <a:t>D1–D3 Denied</a:t>
+              <a:t>Commit + Path + Line</a:t>
             </a:r>
           </a:p>
           <a:p xmlns:a="http://schemas.openxmlformats.org/drawingml/2006/main">
@@ -7713,7 +8013,7 @@
               </a:defRPr>
             </a:pPr>
             <a:r>
-              <a:t>Prompt Injection</a:t>
+              <a:t>Symbol Resolvable</a:t>
             </a:r>
           </a:p>
           <a:p xmlns:a="http://schemas.openxmlformats.org/drawingml/2006/main">
@@ -7729,7 +8029,7 @@
               </a:defRPr>
             </a:pPr>
             <a:r>
-              <a:t>No Tool Execution</a:t>
+              <a:t>Test-only 0</a:t>
             </a:r>
           </a:p>
         </p:txBody>
@@ -7804,7 +8104,7 @@
               </a:defRPr>
             </a:pPr>
             <a:r>
-              <a:t>E2E</a:t>
+              <a:t>Safety</a:t>
             </a:r>
           </a:p>
         </p:txBody>
@@ -7850,7 +8150,7 @@
               </a:defRPr>
             </a:pPr>
             <a:r>
-              <a:t>Release Gate</a:t>
+              <a:t>Static Only</a:t>
             </a:r>
           </a:p>
         </p:txBody>
@@ -7896,7 +8196,7 @@
               </a:defRPr>
             </a:pPr>
             <a:r>
-              <a:t>12 Contract Tests</a:t>
+              <a:t>Hook · Build · Test 0</a:t>
             </a:r>
           </a:p>
           <a:p xmlns:a="http://schemas.openxmlformats.org/drawingml/2006/main">
@@ -7912,7 +8212,7 @@
               </a:defRPr>
             </a:pPr>
             <a:r>
-              <a:t>Deletion Drill</a:t>
+              <a:t>Secret · Binary 0</a:t>
             </a:r>
           </a:p>
           <a:p xmlns:a="http://schemas.openxmlformats.org/drawingml/2006/main">
@@ -7928,7 +8228,7 @@
               </a:defRPr>
             </a:pPr>
             <a:r>
-              <a:t>ANSWERED / ABSTAINED / FAILED</a:t>
+              <a:t>AI Tool 0</a:t>
             </a:r>
           </a:p>
         </p:txBody>
@@ -7974,7 +8274,7 @@
               </a:defRPr>
             </a:pPr>
             <a:r>
-              <a:t>Source Docs</a:t>
+              <a:t>50 Questions</a:t>
             </a:r>
           </a:p>
         </p:txBody>
@@ -8047,7 +8347,7 @@
               </a:defRPr>
             </a:pPr>
             <a:r>
-              <a:t>APIs</a:t>
+              <a:t>20 Code</a:t>
             </a:r>
           </a:p>
         </p:txBody>
@@ -8120,7 +8420,7 @@
               </a:defRPr>
             </a:pPr>
             <a:r>
-              <a:t>Work Items</a:t>
+              <a:t>22 Contract Tests</a:t>
             </a:r>
           </a:p>
         </p:txBody>
@@ -8215,7 +8515,7 @@
               </a:defRPr>
             </a:pPr>
             <a:r>
-              <a:t>설계·운영·검증을 하나의 제품 자산으로 묶었습니다</a:t>
+              <a:t>개정 설계·운영·검증을 같은 제품 자산으로 유지합니다</a:t>
             </a:r>
           </a:p>
         </p:txBody>
@@ -8307,7 +8607,7 @@
               </a:defRPr>
             </a:pPr>
             <a:r>
-              <a:t>하위 이슈는 동일 계약과 완료 기준을 공유합니다.</a:t>
+              <a:t>Issue #20의 안정적인 파일명과 링크는 유지하고 내용·체크섬을 갱신합니다.</a:t>
             </a:r>
           </a:p>
         </p:txBody>
@@ -8428,7 +8728,7 @@
               </a:defRPr>
             </a:pPr>
             <a:r>
-              <a:t>ADR-0008</a:t>
+              <a:t>ADR-0008 Revised</a:t>
             </a:r>
           </a:p>
           <a:p xmlns:a="http://schemas.openxmlformats.org/drawingml/2006/main">
@@ -8460,7 +8760,7 @@
               </a:defRPr>
             </a:pPr>
             <a:r>
-              <a:t>Contract JSON</a:t>
+              <a:t>Contract v1.2</a:t>
             </a:r>
           </a:p>
         </p:txBody>
@@ -8581,7 +8881,7 @@
               </a:defRPr>
             </a:pPr>
             <a:r>
-              <a:t>Development Runbook</a:t>
+              <a:t>Fetcher · Parser Runbook</a:t>
             </a:r>
           </a:p>
           <a:p xmlns:a="http://schemas.openxmlformats.org/drawingml/2006/main">
@@ -8613,7 +8913,7 @@
               </a:defRPr>
             </a:pPr>
             <a:r>
-              <a:t>Deletion Procedure</a:t>
+              <a:t>Deletion Drill</a:t>
             </a:r>
           </a:p>
         </p:txBody>
@@ -8734,7 +9034,7 @@
               </a:defRPr>
             </a:pPr>
             <a:r>
-              <a:t>Contract Validator</a:t>
+              <a:t>22 Contract Tests</a:t>
             </a:r>
           </a:p>
           <a:p xmlns:a="http://schemas.openxmlformats.org/drawingml/2006/main">
@@ -8750,7 +9050,7 @@
               </a:defRPr>
             </a:pPr>
             <a:r>
-              <a:t>12 Unit Tests</a:t>
+              <a:t>Report · Deck</a:t>
             </a:r>
           </a:p>
           <a:p xmlns:a="http://schemas.openxmlformats.org/drawingml/2006/main">
@@ -8766,7 +9066,7 @@
               </a:defRPr>
             </a:pPr>
             <a:r>
-              <a:t>Report · Deck · Manifest</a:t>
+              <a:t>Artifact Manifest</a:t>
             </a:r>
           </a:p>
         </p:txBody>
@@ -8841,7 +9141,7 @@
               </a:defRPr>
             </a:pPr>
             <a:r>
-              <a:t>Issue #20 기준  |  D0 only · Citation required · No agency · Deletion ≤ 7d</a:t>
+              <a:t>Issue #20  |  7 Repositories · 9 Profiles · Compatibility-aware</a:t>
             </a:r>
           </a:p>
         </p:txBody>
@@ -8909,7 +9209,7 @@
               </a:defRPr>
             </a:pPr>
             <a:r>
-              <a:t>#41부터 #46까지 의존 순서대로 구현합니다</a:t>
+              <a:t>#41부터 #46까지 코드 분석 범위를 포함해 실행합니다</a:t>
             </a:r>
           </a:p>
         </p:txBody>
@@ -9001,7 +9301,7 @@
               </a:defRPr>
             </a:pPr>
             <a:r>
-              <a:t>각 작업은 독립 완료 기준과 다음 단계 입력을 가집니다.</a:t>
+              <a:t>기존 이슈 번호와 의존 순서를 유지하면서 완료 기준을 개정합니다.</a:t>
             </a:r>
           </a:p>
         </p:txBody>
@@ -9420,7 +9720,7 @@
               </a:defRPr>
             </a:pPr>
             <a:r>
-              <a:t>Gateway Skeleton</a:t>
+              <a:t>Profiles · API</a:t>
             </a:r>
           </a:p>
           <a:p xmlns:a="http://schemas.openxmlformats.org/drawingml/2006/main">
@@ -9436,7 +9736,7 @@
               </a:defRPr>
             </a:pPr>
             <a:r>
-              <a:t>API + DB</a:t>
+              <a:t>Compatibility DB</a:t>
             </a:r>
           </a:p>
         </p:txBody>
@@ -9528,7 +9828,7 @@
               </a:defRPr>
             </a:pPr>
             <a:r>
-              <a:t>Registry</a:t>
+              <a:t>9 Profiles</a:t>
             </a:r>
           </a:p>
           <a:p xmlns:a="http://schemas.openxmlformats.org/drawingml/2006/main">
@@ -9544,7 +9844,7 @@
               </a:defRPr>
             </a:pPr>
             <a:r>
-              <a:t>Quarantine</a:t>
+              <a:t>Pinned Fetch</a:t>
             </a:r>
           </a:p>
         </p:txBody>
@@ -9636,7 +9936,7 @@
               </a:defRPr>
             </a:pPr>
             <a:r>
-              <a:t>Chunk · Embed</a:t>
+              <a:t>Parser · Symbol</a:t>
             </a:r>
           </a:p>
           <a:p xmlns:a="http://schemas.openxmlformats.org/drawingml/2006/main">
@@ -9652,7 +9952,7 @@
               </a:defRPr>
             </a:pPr>
             <a:r>
-              <a:t>Hybrid Search</a:t>
+              <a:t>FTS · ID · Vector</a:t>
             </a:r>
           </a:p>
         </p:txBody>
@@ -9744,7 +10044,7 @@
               </a:defRPr>
             </a:pPr>
             <a:r>
-              <a:t>Citation</a:t>
+              <a:t>Branch Citation</a:t>
             </a:r>
           </a:p>
           <a:p xmlns:a="http://schemas.openxmlformats.org/drawingml/2006/main">
@@ -9760,7 +10060,7 @@
               </a:defRPr>
             </a:pPr>
             <a:r>
-              <a:t>Provider Adapter</a:t>
+              <a:t>Abstention</a:t>
             </a:r>
           </a:p>
         </p:txBody>
@@ -9835,7 +10135,7 @@
               </a:defRPr>
             </a:pPr>
             <a:r>
-              <a:t>후속 = #45 Activepieces 연동 → #46 Golden Set·보안·E2E 검증</a:t>
+              <a:t>후속 = #45 문서·코드 Activepieces Flow → #46 50개 Golden Set·E2E</a:t>
             </a:r>
           </a:p>
         </p:txBody>

</xml_diff>

<commit_message>
Issue #20 OpenAI RAG 런타임 설계 보강
</commit_message>
<xml_diff>
--- a/output/presentation/techflow-rag-poc-design.pptx
+++ b/output/presentation/techflow-rag-poc-design.pptx
@@ -2,22 +2,22 @@
 <file path=ppt/presentation.xml><?xml version="1.0" encoding="utf-8"?>
 <p:presentation xmlns:p="http://schemas.openxmlformats.org/presentationml/2006/main">
   <p:sldMasterIdLst>
-    <p:sldMasterId xmlns:r="http://schemas.openxmlformats.org/officeDocument/2006/relationships" id="2147483648" r:id="Rae74aed7dea744b3"/>
+    <p:sldMasterId xmlns:r="http://schemas.openxmlformats.org/officeDocument/2006/relationships" id="2147483648" r:id="Rd06970957ce6450b"/>
   </p:sldMasterIdLst>
   <p:notesMasterIdLst>
-    <p:notesMasterId xmlns:r="http://schemas.openxmlformats.org/officeDocument/2006/relationships" r:id="R8b272f8c45db4723"/>
+    <p:notesMasterId xmlns:r="http://schemas.openxmlformats.org/officeDocument/2006/relationships" r:id="R69b04556d0124c7a"/>
   </p:notesMasterIdLst>
   <p:sldIdLst>
-    <p:sldId xmlns:r="http://schemas.openxmlformats.org/officeDocument/2006/relationships" id="256" r:id="R2bfaedd7a7a64c56"/>
-    <p:sldId xmlns:r="http://schemas.openxmlformats.org/officeDocument/2006/relationships" id="257" r:id="R836b0788e4af45ac"/>
-    <p:sldId xmlns:r="http://schemas.openxmlformats.org/officeDocument/2006/relationships" id="258" r:id="R199bbb7ab8aa41ef"/>
-    <p:sldId xmlns:r="http://schemas.openxmlformats.org/officeDocument/2006/relationships" id="259" r:id="R1d8259b1b60d439d"/>
-    <p:sldId xmlns:r="http://schemas.openxmlformats.org/officeDocument/2006/relationships" id="260" r:id="R197217479e4f4caa"/>
-    <p:sldId xmlns:r="http://schemas.openxmlformats.org/officeDocument/2006/relationships" id="261" r:id="R8eee312b8780451f"/>
-    <p:sldId xmlns:r="http://schemas.openxmlformats.org/officeDocument/2006/relationships" id="262" r:id="R31f74510c057477a"/>
-    <p:sldId xmlns:r="http://schemas.openxmlformats.org/officeDocument/2006/relationships" id="263" r:id="R8fbe8c7eb8ee4b6b"/>
-    <p:sldId xmlns:r="http://schemas.openxmlformats.org/officeDocument/2006/relationships" id="264" r:id="Ra3e28197686d44ea"/>
-    <p:sldId xmlns:r="http://schemas.openxmlformats.org/officeDocument/2006/relationships" id="265" r:id="Re9b451bf442c4d85"/>
+    <p:sldId xmlns:r="http://schemas.openxmlformats.org/officeDocument/2006/relationships" id="256" r:id="R7e1bc4ee87c14bf4"/>
+    <p:sldId xmlns:r="http://schemas.openxmlformats.org/officeDocument/2006/relationships" id="257" r:id="Rbf0fd448744a4e07"/>
+    <p:sldId xmlns:r="http://schemas.openxmlformats.org/officeDocument/2006/relationships" id="258" r:id="R57cf6275552b4d1e"/>
+    <p:sldId xmlns:r="http://schemas.openxmlformats.org/officeDocument/2006/relationships" id="259" r:id="R971bec9ea2d9476f"/>
+    <p:sldId xmlns:r="http://schemas.openxmlformats.org/officeDocument/2006/relationships" id="260" r:id="R333a23bbc93848d7"/>
+    <p:sldId xmlns:r="http://schemas.openxmlformats.org/officeDocument/2006/relationships" id="261" r:id="R635ee2892b4e4a41"/>
+    <p:sldId xmlns:r="http://schemas.openxmlformats.org/officeDocument/2006/relationships" id="262" r:id="Rd4204e76ac544f99"/>
+    <p:sldId xmlns:r="http://schemas.openxmlformats.org/officeDocument/2006/relationships" id="263" r:id="R983f10a0aa81467d"/>
+    <p:sldId xmlns:r="http://schemas.openxmlformats.org/officeDocument/2006/relationships" id="264" r:id="R1a439e312d4b421a"/>
+    <p:sldId xmlns:r="http://schemas.openxmlformats.org/officeDocument/2006/relationships" id="265" r:id="R693841bf270d4d13"/>
   </p:sldIdLst>
   <p:sldSz cx="12192000" cy="6858000"/>
   <p:notesSz cx="6858000" cy="9144000"/>
@@ -521,6 +521,31 @@
           </a:p>
           <a:p xmlns:a="http://schemas.openxmlformats.org/drawingml/2006/main">
             <a:r>
+              <a:t>- docs/adr/0009-openai-runtime-integration.md</a:t>
+            </a:r>
+          </a:p>
+          <a:p xmlns:a="http://schemas.openxmlformats.org/drawingml/2006/main">
+            <a:r>
+              <a:t>- https://developers.openai.com/api/docs/guides/latest-model</a:t>
+            </a:r>
+          </a:p>
+          <a:p xmlns:a="http://schemas.openxmlformats.org/drawingml/2006/main">
+            <a:r>
+              <a:t>- https://developers.openai.com/api/docs/guides/structured-outputs</a:t>
+            </a:r>
+          </a:p>
+          <a:p xmlns:a="http://schemas.openxmlformats.org/drawingml/2006/main">
+            <a:r>
+              <a:t>- https://developers.openai.com/api/docs/guides/embeddings</a:t>
+            </a:r>
+          </a:p>
+          <a:p xmlns:a="http://schemas.openxmlformats.org/drawingml/2006/main">
+            <a:r>
+              <a:t>- https://platform.openai.com/docs/models/default-usage-policies-by-endpoint</a:t>
+            </a:r>
+          </a:p>
+          <a:p xmlns:a="http://schemas.openxmlformats.org/drawingml/2006/main">
+            <a:r>
               <a:t>[/Sources]</a:t>
             </a:r>
           </a:p>
@@ -661,6 +686,31 @@
           </a:p>
           <a:p xmlns:a="http://schemas.openxmlformats.org/drawingml/2006/main">
             <a:r>
+              <a:t>- docs/adr/0009-openai-runtime-integration.md</a:t>
+            </a:r>
+          </a:p>
+          <a:p xmlns:a="http://schemas.openxmlformats.org/drawingml/2006/main">
+            <a:r>
+              <a:t>- https://developers.openai.com/api/docs/guides/latest-model</a:t>
+            </a:r>
+          </a:p>
+          <a:p xmlns:a="http://schemas.openxmlformats.org/drawingml/2006/main">
+            <a:r>
+              <a:t>- https://developers.openai.com/api/docs/guides/structured-outputs</a:t>
+            </a:r>
+          </a:p>
+          <a:p xmlns:a="http://schemas.openxmlformats.org/drawingml/2006/main">
+            <a:r>
+              <a:t>- https://developers.openai.com/api/docs/guides/embeddings</a:t>
+            </a:r>
+          </a:p>
+          <a:p xmlns:a="http://schemas.openxmlformats.org/drawingml/2006/main">
+            <a:r>
+              <a:t>- https://platform.openai.com/docs/models/default-usage-policies-by-endpoint</a:t>
+            </a:r>
+          </a:p>
+          <a:p xmlns:a="http://schemas.openxmlformats.org/drawingml/2006/main">
+            <a:r>
               <a:t>[/Sources]</a:t>
             </a:r>
           </a:p>
@@ -801,6 +851,31 @@
           </a:p>
           <a:p xmlns:a="http://schemas.openxmlformats.org/drawingml/2006/main">
             <a:r>
+              <a:t>- docs/adr/0009-openai-runtime-integration.md</a:t>
+            </a:r>
+          </a:p>
+          <a:p xmlns:a="http://schemas.openxmlformats.org/drawingml/2006/main">
+            <a:r>
+              <a:t>- https://developers.openai.com/api/docs/guides/latest-model</a:t>
+            </a:r>
+          </a:p>
+          <a:p xmlns:a="http://schemas.openxmlformats.org/drawingml/2006/main">
+            <a:r>
+              <a:t>- https://developers.openai.com/api/docs/guides/structured-outputs</a:t>
+            </a:r>
+          </a:p>
+          <a:p xmlns:a="http://schemas.openxmlformats.org/drawingml/2006/main">
+            <a:r>
+              <a:t>- https://developers.openai.com/api/docs/guides/embeddings</a:t>
+            </a:r>
+          </a:p>
+          <a:p xmlns:a="http://schemas.openxmlformats.org/drawingml/2006/main">
+            <a:r>
+              <a:t>- https://platform.openai.com/docs/models/default-usage-policies-by-endpoint</a:t>
+            </a:r>
+          </a:p>
+          <a:p xmlns:a="http://schemas.openxmlformats.org/drawingml/2006/main">
+            <a:r>
               <a:t>[/Sources]</a:t>
             </a:r>
           </a:p>
@@ -941,6 +1016,31 @@
           </a:p>
           <a:p xmlns:a="http://schemas.openxmlformats.org/drawingml/2006/main">
             <a:r>
+              <a:t>- docs/adr/0009-openai-runtime-integration.md</a:t>
+            </a:r>
+          </a:p>
+          <a:p xmlns:a="http://schemas.openxmlformats.org/drawingml/2006/main">
+            <a:r>
+              <a:t>- https://developers.openai.com/api/docs/guides/latest-model</a:t>
+            </a:r>
+          </a:p>
+          <a:p xmlns:a="http://schemas.openxmlformats.org/drawingml/2006/main">
+            <a:r>
+              <a:t>- https://developers.openai.com/api/docs/guides/structured-outputs</a:t>
+            </a:r>
+          </a:p>
+          <a:p xmlns:a="http://schemas.openxmlformats.org/drawingml/2006/main">
+            <a:r>
+              <a:t>- https://developers.openai.com/api/docs/guides/embeddings</a:t>
+            </a:r>
+          </a:p>
+          <a:p xmlns:a="http://schemas.openxmlformats.org/drawingml/2006/main">
+            <a:r>
+              <a:t>- https://platform.openai.com/docs/models/default-usage-policies-by-endpoint</a:t>
+            </a:r>
+          </a:p>
+          <a:p xmlns:a="http://schemas.openxmlformats.org/drawingml/2006/main">
+            <a:r>
               <a:t>[/Sources]</a:t>
             </a:r>
           </a:p>
@@ -1081,6 +1181,31 @@
           </a:p>
           <a:p xmlns:a="http://schemas.openxmlformats.org/drawingml/2006/main">
             <a:r>
+              <a:t>- docs/adr/0009-openai-runtime-integration.md</a:t>
+            </a:r>
+          </a:p>
+          <a:p xmlns:a="http://schemas.openxmlformats.org/drawingml/2006/main">
+            <a:r>
+              <a:t>- https://developers.openai.com/api/docs/guides/latest-model</a:t>
+            </a:r>
+          </a:p>
+          <a:p xmlns:a="http://schemas.openxmlformats.org/drawingml/2006/main">
+            <a:r>
+              <a:t>- https://developers.openai.com/api/docs/guides/structured-outputs</a:t>
+            </a:r>
+          </a:p>
+          <a:p xmlns:a="http://schemas.openxmlformats.org/drawingml/2006/main">
+            <a:r>
+              <a:t>- https://developers.openai.com/api/docs/guides/embeddings</a:t>
+            </a:r>
+          </a:p>
+          <a:p xmlns:a="http://schemas.openxmlformats.org/drawingml/2006/main">
+            <a:r>
+              <a:t>- https://platform.openai.com/docs/models/default-usage-policies-by-endpoint</a:t>
+            </a:r>
+          </a:p>
+          <a:p xmlns:a="http://schemas.openxmlformats.org/drawingml/2006/main">
+            <a:r>
               <a:t>[/Sources]</a:t>
             </a:r>
           </a:p>
@@ -1221,6 +1346,31 @@
           </a:p>
           <a:p xmlns:a="http://schemas.openxmlformats.org/drawingml/2006/main">
             <a:r>
+              <a:t>- docs/adr/0009-openai-runtime-integration.md</a:t>
+            </a:r>
+          </a:p>
+          <a:p xmlns:a="http://schemas.openxmlformats.org/drawingml/2006/main">
+            <a:r>
+              <a:t>- https://developers.openai.com/api/docs/guides/latest-model</a:t>
+            </a:r>
+          </a:p>
+          <a:p xmlns:a="http://schemas.openxmlformats.org/drawingml/2006/main">
+            <a:r>
+              <a:t>- https://developers.openai.com/api/docs/guides/structured-outputs</a:t>
+            </a:r>
+          </a:p>
+          <a:p xmlns:a="http://schemas.openxmlformats.org/drawingml/2006/main">
+            <a:r>
+              <a:t>- https://developers.openai.com/api/docs/guides/embeddings</a:t>
+            </a:r>
+          </a:p>
+          <a:p xmlns:a="http://schemas.openxmlformats.org/drawingml/2006/main">
+            <a:r>
+              <a:t>- https://platform.openai.com/docs/models/default-usage-policies-by-endpoint</a:t>
+            </a:r>
+          </a:p>
+          <a:p xmlns:a="http://schemas.openxmlformats.org/drawingml/2006/main">
+            <a:r>
               <a:t>[/Sources]</a:t>
             </a:r>
           </a:p>
@@ -1361,6 +1511,31 @@
           </a:p>
           <a:p xmlns:a="http://schemas.openxmlformats.org/drawingml/2006/main">
             <a:r>
+              <a:t>- docs/adr/0009-openai-runtime-integration.md</a:t>
+            </a:r>
+          </a:p>
+          <a:p xmlns:a="http://schemas.openxmlformats.org/drawingml/2006/main">
+            <a:r>
+              <a:t>- https://developers.openai.com/api/docs/guides/latest-model</a:t>
+            </a:r>
+          </a:p>
+          <a:p xmlns:a="http://schemas.openxmlformats.org/drawingml/2006/main">
+            <a:r>
+              <a:t>- https://developers.openai.com/api/docs/guides/structured-outputs</a:t>
+            </a:r>
+          </a:p>
+          <a:p xmlns:a="http://schemas.openxmlformats.org/drawingml/2006/main">
+            <a:r>
+              <a:t>- https://developers.openai.com/api/docs/guides/embeddings</a:t>
+            </a:r>
+          </a:p>
+          <a:p xmlns:a="http://schemas.openxmlformats.org/drawingml/2006/main">
+            <a:r>
+              <a:t>- https://platform.openai.com/docs/models/default-usage-policies-by-endpoint</a:t>
+            </a:r>
+          </a:p>
+          <a:p xmlns:a="http://schemas.openxmlformats.org/drawingml/2006/main">
+            <a:r>
               <a:t>[/Sources]</a:t>
             </a:r>
           </a:p>
@@ -1501,6 +1676,31 @@
           </a:p>
           <a:p xmlns:a="http://schemas.openxmlformats.org/drawingml/2006/main">
             <a:r>
+              <a:t>- docs/adr/0009-openai-runtime-integration.md</a:t>
+            </a:r>
+          </a:p>
+          <a:p xmlns:a="http://schemas.openxmlformats.org/drawingml/2006/main">
+            <a:r>
+              <a:t>- https://developers.openai.com/api/docs/guides/latest-model</a:t>
+            </a:r>
+          </a:p>
+          <a:p xmlns:a="http://schemas.openxmlformats.org/drawingml/2006/main">
+            <a:r>
+              <a:t>- https://developers.openai.com/api/docs/guides/structured-outputs</a:t>
+            </a:r>
+          </a:p>
+          <a:p xmlns:a="http://schemas.openxmlformats.org/drawingml/2006/main">
+            <a:r>
+              <a:t>- https://developers.openai.com/api/docs/guides/embeddings</a:t>
+            </a:r>
+          </a:p>
+          <a:p xmlns:a="http://schemas.openxmlformats.org/drawingml/2006/main">
+            <a:r>
+              <a:t>- https://platform.openai.com/docs/models/default-usage-policies-by-endpoint</a:t>
+            </a:r>
+          </a:p>
+          <a:p xmlns:a="http://schemas.openxmlformats.org/drawingml/2006/main">
+            <a:r>
               <a:t>[/Sources]</a:t>
             </a:r>
           </a:p>
@@ -1641,6 +1841,31 @@
           </a:p>
           <a:p xmlns:a="http://schemas.openxmlformats.org/drawingml/2006/main">
             <a:r>
+              <a:t>- docs/adr/0009-openai-runtime-integration.md</a:t>
+            </a:r>
+          </a:p>
+          <a:p xmlns:a="http://schemas.openxmlformats.org/drawingml/2006/main">
+            <a:r>
+              <a:t>- https://developers.openai.com/api/docs/guides/latest-model</a:t>
+            </a:r>
+          </a:p>
+          <a:p xmlns:a="http://schemas.openxmlformats.org/drawingml/2006/main">
+            <a:r>
+              <a:t>- https://developers.openai.com/api/docs/guides/structured-outputs</a:t>
+            </a:r>
+          </a:p>
+          <a:p xmlns:a="http://schemas.openxmlformats.org/drawingml/2006/main">
+            <a:r>
+              <a:t>- https://developers.openai.com/api/docs/guides/embeddings</a:t>
+            </a:r>
+          </a:p>
+          <a:p xmlns:a="http://schemas.openxmlformats.org/drawingml/2006/main">
+            <a:r>
+              <a:t>- https://platform.openai.com/docs/models/default-usage-policies-by-endpoint</a:t>
+            </a:r>
+          </a:p>
+          <a:p xmlns:a="http://schemas.openxmlformats.org/drawingml/2006/main">
+            <a:r>
               <a:t>[/Sources]</a:t>
             </a:r>
           </a:p>
@@ -1777,6 +2002,31 @@
           <a:p xmlns:a="http://schemas.openxmlformats.org/drawingml/2006/main">
             <a:r>
               <a:t>- https://docs.github.com/en/rest/git/trees</a:t>
+            </a:r>
+          </a:p>
+          <a:p xmlns:a="http://schemas.openxmlformats.org/drawingml/2006/main">
+            <a:r>
+              <a:t>- docs/adr/0009-openai-runtime-integration.md</a:t>
+            </a:r>
+          </a:p>
+          <a:p xmlns:a="http://schemas.openxmlformats.org/drawingml/2006/main">
+            <a:r>
+              <a:t>- https://developers.openai.com/api/docs/guides/latest-model</a:t>
+            </a:r>
+          </a:p>
+          <a:p xmlns:a="http://schemas.openxmlformats.org/drawingml/2006/main">
+            <a:r>
+              <a:t>- https://developers.openai.com/api/docs/guides/structured-outputs</a:t>
+            </a:r>
+          </a:p>
+          <a:p xmlns:a="http://schemas.openxmlformats.org/drawingml/2006/main">
+            <a:r>
+              <a:t>- https://developers.openai.com/api/docs/guides/embeddings</a:t>
+            </a:r>
+          </a:p>
+          <a:p xmlns:a="http://schemas.openxmlformats.org/drawingml/2006/main">
+            <a:r>
+              <a:t>- https://platform.openai.com/docs/models/default-usage-policies-by-endpoint</a:t>
             </a:r>
           </a:p>
           <a:p xmlns:a="http://schemas.openxmlformats.org/drawingml/2006/main">
@@ -1849,7 +2099,7 @@
   </p:cSld>
   <p:clrMap bg1="lt1" tx1="dk1" bg2="lt2" tx2="dk2" accent1="accent1" accent2="accent2" accent3="accent3" accent4="accent4" accent5="accent5" accent6="accent6" hlink="hlink" folHlink="folHlink"/>
   <p:sldLayoutIdLst>
-    <p:sldLayoutId xmlns:r="http://schemas.openxmlformats.org/officeDocument/2006/relationships" id="2147483649" r:id="Rf277b2bf52404aae"/>
+    <p:sldLayoutId xmlns:r="http://schemas.openxmlformats.org/officeDocument/2006/relationships" id="2147483649" r:id="R649653772b6a4c2d"/>
   </p:sldLayoutIdLst>
   <p:txStyles>
     <p:titleStyle>
@@ -2475,7 +2725,7 @@
               </a:defRPr>
             </a:pPr>
             <a:r>
-              <a:t>문서와 소스코드를 함께 쓰는</a:t>
+              <a:t>문서·코드 + OpenAI</a:t>
             </a:r>
           </a:p>
           <a:p xmlns:a="http://schemas.openxmlformats.org/drawingml/2006/main">
@@ -2537,7 +2787,7 @@
               </a:defRPr>
             </a:pPr>
             <a:r>
-              <a:t>Docs + 6 Source Repositories · 9 Profiles · No Code Execution</a:t>
+              <a:t>Local Retrieval · OpenAI Responses / Embeddings · Tool 0</a:t>
             </a:r>
           </a:p>
         </p:txBody>
@@ -2678,7 +2928,7 @@
               </a:defRPr>
             </a:pPr>
             <a:r>
-              <a:t>개정 승인 요청</a:t>
+              <a:t>OpenAI 런타임 설계 승인 요청</a:t>
             </a:r>
           </a:p>
         </p:txBody>
@@ -2724,7 +2974,7 @@
               </a:defRPr>
             </a:pPr>
             <a:r>
-              <a:t>7개 저장소·9개 Profile을 승인하면</a:t>
+              <a:t>OpenAI 런타임을 승인하면</a:t>
             </a:r>
           </a:p>
           <a:p xmlns:a="http://schemas.openxmlformats.org/drawingml/2006/main">
@@ -2740,7 +2990,7 @@
               </a:defRPr>
             </a:pPr>
             <a:r>
-              <a:t>#41 구현부터 시작합니다.</a:t>
+              <a:t>#41부터 구현합니다.</a:t>
             </a:r>
           </a:p>
         </p:txBody>
@@ -2861,7 +3111,7 @@
               </a:defRPr>
             </a:pPr>
             <a:r>
-              <a:t>9 PROFILES · 39,836 FILES · COMPATIBILITY GATE · NO CODE EXECUTION</a:t>
+              <a:t>9 PROFILES · OPENAI RESPONSES · LOCAL RAG · TOOL 0</a:t>
             </a:r>
           </a:p>
         </p:txBody>
@@ -2934,7 +3184,7 @@
               </a:defRPr>
             </a:pPr>
             <a:r>
-              <a:t>ABLESTACK TechFlow · Documentation &amp; Source Code RAG Gate</a:t>
+              <a:t>ABLESTACK TechFlow · OpenAI Runtime &amp; Source Code RAG</a:t>
             </a:r>
           </a:p>
         </p:txBody>
@@ -3567,7 +3817,7 @@
               </a:defRPr>
             </a:pPr>
             <a:r>
-              <a:t>9 Profiles  |  39,836 Files  |  14 Tables  |  50 Golden Questions</a:t>
+              <a:t>9 Profiles  |  39,836 Files  |  15 Tables  |  50 Golden Questions</a:t>
             </a:r>
           </a:p>
         </p:txBody>
@@ -4125,7 +4375,7 @@
               </a:defRPr>
             </a:pPr>
             <a:r>
-              <a:t>Branch Policy</a:t>
+              <a:t>OpenAI Adapters</a:t>
             </a:r>
           </a:p>
         </p:txBody>
@@ -4370,7 +4620,7 @@
               </a:defRPr>
             </a:pPr>
             <a:r>
-              <a:t>제품 Gate  |  Branch 격리 · Hook/Build/Test 실행 금지 · Citation 검증</a:t>
+              <a:t>제품 Gate  |  Branch 격리 · 로컬 검색 · Responses API · Tool 0</a:t>
             </a:r>
           </a:p>
         </p:txBody>
@@ -6556,7 +6806,7 @@
               </a:defRPr>
             </a:pPr>
             <a:r>
-              <a:t>Profile과 호환 조합이 선택된 질문만 코드 답변으로 이어집니다</a:t>
+              <a:t>로컬 검색 결과만 OpenAI API에 전달합니다</a:t>
             </a:r>
           </a:p>
         </p:txBody>
@@ -6648,7 +6898,7 @@
               </a:defRPr>
             </a:pPr>
             <a:r>
-              <a:t>Cloud Branch나 저장소 조합이 충돌하면 임의 선택하지 않고 보류합니다.</a:t>
+              <a:t>원본 저장소는 내부에 유지하고 최종 D0 Chunk와 Citation만 전송합니다.</a:t>
             </a:r>
           </a:p>
         </p:txBody>
@@ -6893,7 +7143,7 @@
               </a:defRPr>
             </a:pPr>
             <a:r>
-              <a:t>Source Profiles</a:t>
+              <a:t>Profile / Set</a:t>
             </a:r>
           </a:p>
         </p:txBody>
@@ -6952,7 +7202,7 @@
         </p:spPr>
         <p:txBody>
           <a:bodyPr xmlns:a="http://schemas.openxmlformats.org/drawingml/2006/main" lIns="0" tIns="0" rIns="0" bIns="0" anchor="t">
-            <a:normAutofit fontScale="83156"/>
+            <a:normAutofit fontScale="100000"/>
           </a:bodyPr>
           <a:lstStyle xmlns:a="http://schemas.openxmlformats.org/drawingml/2006/main"/>
           <a:p xmlns:a="http://schemas.openxmlformats.org/drawingml/2006/main">
@@ -6968,7 +7218,7 @@
               </a:defRPr>
             </a:pPr>
             <a:r>
-              <a:t>TechFlow AI Gateway</a:t>
+              <a:t>AI Gateway</a:t>
             </a:r>
           </a:p>
         </p:txBody>
@@ -7014,7 +7264,7 @@
               </a:defRPr>
             </a:pPr>
             <a:r>
-              <a:t>Compatibility Gate</a:t>
+              <a:t>Gate · RRF</a:t>
             </a:r>
           </a:p>
           <a:p xmlns:a="http://schemas.openxmlformats.org/drawingml/2006/main">
@@ -7030,7 +7280,7 @@
               </a:defRPr>
             </a:pPr>
             <a:r>
-              <a:t>RRF · Citation</a:t>
+              <a:t>Route · Validate</a:t>
             </a:r>
           </a:p>
         </p:txBody>
@@ -7167,7 +7417,7 @@
               </a:defRPr>
             </a:pPr>
             <a:r>
-              <a:t>FTS · Vector</a:t>
+              <a:t>FTS · ID · Vector</a:t>
             </a:r>
           </a:p>
         </p:txBody>
@@ -7226,7 +7476,7 @@
         </p:spPr>
         <p:txBody>
           <a:bodyPr xmlns:a="http://schemas.openxmlformats.org/drawingml/2006/main" lIns="0" tIns="0" rIns="0" bIns="0" anchor="t">
-            <a:normAutofit fontScale="89712"/>
+            <a:normAutofit fontScale="100000"/>
           </a:bodyPr>
           <a:lstStyle xmlns:a="http://schemas.openxmlformats.org/drawingml/2006/main"/>
           <a:p xmlns:a="http://schemas.openxmlformats.org/drawingml/2006/main">
@@ -7242,7 +7492,7 @@
               </a:defRPr>
             </a:pPr>
             <a:r>
-              <a:t>Model Provider</a:t>
+              <a:t>OpenAI API</a:t>
             </a:r>
           </a:p>
         </p:txBody>
@@ -7272,7 +7522,7 @@
         </p:spPr>
         <p:txBody>
           <a:bodyPr xmlns:a="http://schemas.openxmlformats.org/drawingml/2006/main" lIns="0" tIns="0" rIns="0" bIns="0" anchor="t">
-            <a:normAutofit fontScale="89506"/>
+            <a:normAutofit fontScale="100000"/>
           </a:bodyPr>
           <a:lstStyle xmlns:a="http://schemas.openxmlformats.org/drawingml/2006/main"/>
           <a:p xmlns:a="http://schemas.openxmlformats.org/drawingml/2006/main">
@@ -7288,7 +7538,7 @@
               </a:defRPr>
             </a:pPr>
             <a:r>
-              <a:t>Minimal Context</a:t>
+              <a:t>Responses</a:t>
             </a:r>
           </a:p>
           <a:p xmlns:a="http://schemas.openxmlformats.org/drawingml/2006/main">
@@ -7304,7 +7554,7 @@
               </a:defRPr>
             </a:pPr>
             <a:r>
-              <a:t>No Tool / Training</a:t>
+              <a:t>Terra / Sol</a:t>
             </a:r>
           </a:p>
         </p:txBody>
@@ -7379,7 +7629,7 @@
               </a:defRPr>
             </a:pPr>
             <a:r>
-              <a:t>D0 Only</a:t>
+              <a:t>Embeddings API</a:t>
             </a:r>
           </a:p>
         </p:txBody>
@@ -7425,7 +7675,7 @@
               </a:defRPr>
             </a:pPr>
             <a:r>
-              <a:t>Line Citations</a:t>
+              <a:t>text-embedding-3-large</a:t>
             </a:r>
           </a:p>
         </p:txBody>
@@ -7471,7 +7721,7 @@
               </a:defRPr>
             </a:pPr>
             <a:r>
-              <a:t>외부 경계</a:t>
+              <a:t>TechFlow 내부</a:t>
             </a:r>
           </a:p>
         </p:txBody>
@@ -7517,7 +7767,7 @@
               </a:defRPr>
             </a:pPr>
             <a:r>
-              <a:t>제품 경계</a:t>
+              <a:t>OpenAI 경계</a:t>
             </a:r>
           </a:p>
         </p:txBody>
@@ -7569,7 +7819,7 @@
         </p:spPr>
         <p:txBody>
           <a:bodyPr xmlns:a="http://schemas.openxmlformats.org/drawingml/2006/main" lIns="0" tIns="0" rIns="0" bIns="0" anchor="t">
-            <a:normAutofit fontScale="98942"/>
+            <a:normAutofit fontScale="100000"/>
           </a:bodyPr>
           <a:lstStyle xmlns:a="http://schemas.openxmlformats.org/drawingml/2006/main"/>
           <a:p xmlns:a="http://schemas.openxmlformats.org/drawingml/2006/main">
@@ -7585,7 +7835,7 @@
               </a:defRPr>
             </a:pPr>
             <a:r>
-              <a:t>Branch·저장소 격리와 코드 Citation을 품질 Gate로 추가했습니다</a:t>
+              <a:t>Terra 기본, Sol 승격을 호출 전에 결정합니다</a:t>
             </a:r>
           </a:p>
         </p:txBody>
@@ -7690,7 +7940,7 @@
         </p:spPr>
         <p:txBody>
           <a:bodyPr xmlns:a="http://schemas.openxmlformats.org/drawingml/2006/main" lIns="0" tIns="0" rIns="0" bIns="0" anchor="t">
-            <a:normAutofit fontScale="71739"/>
+            <a:normAutofit fontScale="100000"/>
           </a:bodyPr>
           <a:lstStyle xmlns:a="http://schemas.openxmlformats.org/drawingml/2006/main"/>
           <a:p xmlns:a="http://schemas.openxmlformats.org/drawingml/2006/main">
@@ -7706,7 +7956,7 @@
               </a:defRPr>
             </a:pPr>
             <a:r>
-              <a:t>Search</a:t>
+              <a:t>Base</a:t>
             </a:r>
           </a:p>
         </p:txBody>
@@ -7752,7 +8002,7 @@
               </a:defRPr>
             </a:pPr>
             <a:r>
-              <a:t>Profile Gate</a:t>
+              <a:t>Terra · medium</a:t>
             </a:r>
           </a:p>
         </p:txBody>
@@ -7798,7 +8048,7 @@
               </a:defRPr>
             </a:pPr>
             <a:r>
-              <a:t>FTS + Identifier</a:t>
+              <a:t>일반 기술지원</a:t>
             </a:r>
           </a:p>
           <a:p xmlns:a="http://schemas.openxmlformats.org/drawingml/2006/main">
@@ -7814,7 +8064,7 @@
               </a:defRPr>
             </a:pPr>
             <a:r>
-              <a:t>Exact Vector</a:t>
+              <a:t>단일 Profile</a:t>
             </a:r>
           </a:p>
           <a:p xmlns:a="http://schemas.openxmlformats.org/drawingml/2006/main">
@@ -7830,7 +8080,7 @@
               </a:defRPr>
             </a:pPr>
             <a:r>
-              <a:t>Cross-Branch 0</a:t>
+              <a:t>한 번 호출</a:t>
             </a:r>
           </a:p>
         </p:txBody>
@@ -7889,7 +8139,7 @@
         </p:spPr>
         <p:txBody>
           <a:bodyPr xmlns:a="http://schemas.openxmlformats.org/drawingml/2006/main" lIns="0" tIns="0" rIns="0" bIns="0" anchor="t">
-            <a:normAutofit fontScale="60935"/>
+            <a:normAutofit fontScale="59925"/>
           </a:bodyPr>
           <a:lstStyle xmlns:a="http://schemas.openxmlformats.org/drawingml/2006/main"/>
           <a:p xmlns:a="http://schemas.openxmlformats.org/drawingml/2006/main">
@@ -7905,7 +8155,7 @@
               </a:defRPr>
             </a:pPr>
             <a:r>
-              <a:t>Citation</a:t>
+              <a:t>Escalate</a:t>
             </a:r>
           </a:p>
         </p:txBody>
@@ -7951,7 +8201,7 @@
               </a:defRPr>
             </a:pPr>
             <a:r>
-              <a:t>Code Lines</a:t>
+              <a:t>Sol · high</a:t>
             </a:r>
           </a:p>
         </p:txBody>
@@ -7997,7 +8247,7 @@
               </a:defRPr>
             </a:pPr>
             <a:r>
-              <a:t>Commit + Path + Line</a:t>
+              <a:t>소스 충돌</a:t>
             </a:r>
           </a:p>
           <a:p xmlns:a="http://schemas.openxmlformats.org/drawingml/2006/main">
@@ -8013,7 +8263,7 @@
               </a:defRPr>
             </a:pPr>
             <a:r>
-              <a:t>Symbol Resolvable</a:t>
+              <a:t>복수 구성요소</a:t>
             </a:r>
           </a:p>
           <a:p xmlns:a="http://schemas.openxmlformats.org/drawingml/2006/main">
@@ -8029,7 +8279,7 @@
               </a:defRPr>
             </a:pPr>
             <a:r>
-              <a:t>Test-only 0</a:t>
+              <a:t>규칙 기반</a:t>
             </a:r>
           </a:p>
         </p:txBody>
@@ -8104,7 +8354,7 @@
               </a:defRPr>
             </a:pPr>
             <a:r>
-              <a:t>Safety</a:t>
+              <a:t>Guard</a:t>
             </a:r>
           </a:p>
         </p:txBody>
@@ -8150,7 +8400,7 @@
               </a:defRPr>
             </a:pPr>
             <a:r>
-              <a:t>Static Only</a:t>
+              <a:t>Tool 0</a:t>
             </a:r>
           </a:p>
         </p:txBody>
@@ -8196,7 +8446,7 @@
               </a:defRPr>
             </a:pPr>
             <a:r>
-              <a:t>Hook · Build · Test 0</a:t>
+              <a:t>store=false</a:t>
             </a:r>
           </a:p>
           <a:p xmlns:a="http://schemas.openxmlformats.org/drawingml/2006/main">
@@ -8212,7 +8462,7 @@
               </a:defRPr>
             </a:pPr>
             <a:r>
-              <a:t>Secret · Binary 0</a:t>
+              <a:t>Structured JSON</a:t>
             </a:r>
           </a:p>
           <a:p xmlns:a="http://schemas.openxmlformats.org/drawingml/2006/main">
@@ -8228,7 +8478,7 @@
               </a:defRPr>
             </a:pPr>
             <a:r>
-              <a:t>AI Tool 0</a:t>
+              <a:t>Citation 재검증</a:t>
             </a:r>
           </a:p>
         </p:txBody>
@@ -8274,7 +8524,7 @@
               </a:defRPr>
             </a:pPr>
             <a:r>
-              <a:t>50 Questions</a:t>
+              <a:t>15 Tables</a:t>
             </a:r>
           </a:p>
         </p:txBody>
@@ -8347,7 +8597,7 @@
               </a:defRPr>
             </a:pPr>
             <a:r>
-              <a:t>20 Code</a:t>
+              <a:t>29 Contract Tests</a:t>
             </a:r>
           </a:p>
         </p:txBody>
@@ -8420,7 +8670,7 @@
               </a:defRPr>
             </a:pPr>
             <a:r>
-              <a:t>22 Contract Tests</a:t>
+              <a:t>No Double Call</a:t>
             </a:r>
           </a:p>
         </p:txBody>
@@ -8728,7 +8978,7 @@
               </a:defRPr>
             </a:pPr>
             <a:r>
-              <a:t>ADR-0008 Revised</a:t>
+              <a:t>ADR-0008 · 0009</a:t>
             </a:r>
           </a:p>
           <a:p xmlns:a="http://schemas.openxmlformats.org/drawingml/2006/main">
@@ -8760,7 +9010,7 @@
               </a:defRPr>
             </a:pPr>
             <a:r>
-              <a:t>Contract v1.2</a:t>
+              <a:t>Contract v1.3</a:t>
             </a:r>
           </a:p>
         </p:txBody>
@@ -8881,7 +9131,7 @@
               </a:defRPr>
             </a:pPr>
             <a:r>
-              <a:t>Fetcher · Parser Runbook</a:t>
+              <a:t>Responses · Embeddings</a:t>
             </a:r>
           </a:p>
           <a:p xmlns:a="http://schemas.openxmlformats.org/drawingml/2006/main">
@@ -8897,23 +9147,23 @@
               </a:defRPr>
             </a:pPr>
             <a:r>
+              <a:t>Data Control Gate</a:t>
+            </a:r>
+          </a:p>
+          <a:p xmlns:a="http://schemas.openxmlformats.org/drawingml/2006/main">
+            <a:pPr algn="l">
+              <a:buNone/>
+              <a:defRPr sz="1575">
+                <a:solidFill>
+                  <a:srgbClr val="111111"/>
+                </a:solidFill>
+                <a:latin typeface="Malgun Gothic"/>
+                <a:ea typeface="Malgun Gothic"/>
+                <a:cs typeface="Malgun Gothic"/>
+              </a:defRPr>
+            </a:pPr>
+            <a:r>
               <a:t>Deploy · Rollback</a:t>
-            </a:r>
-          </a:p>
-          <a:p xmlns:a="http://schemas.openxmlformats.org/drawingml/2006/main">
-            <a:pPr algn="l">
-              <a:buNone/>
-              <a:defRPr sz="1575">
-                <a:solidFill>
-                  <a:srgbClr val="111111"/>
-                </a:solidFill>
-                <a:latin typeface="Malgun Gothic"/>
-                <a:ea typeface="Malgun Gothic"/>
-                <a:cs typeface="Malgun Gothic"/>
-              </a:defRPr>
-            </a:pPr>
-            <a:r>
-              <a:t>Deletion Drill</a:t>
             </a:r>
           </a:p>
         </p:txBody>
@@ -9034,7 +9284,7 @@
               </a:defRPr>
             </a:pPr>
             <a:r>
-              <a:t>22 Contract Tests</a:t>
+              <a:t>29 Contract Tests</a:t>
             </a:r>
           </a:p>
           <a:p xmlns:a="http://schemas.openxmlformats.org/drawingml/2006/main">
@@ -9066,7 +9316,7 @@
               </a:defRPr>
             </a:pPr>
             <a:r>
-              <a:t>Artifact Manifest</a:t>
+              <a:t>15-file Manifest</a:t>
             </a:r>
           </a:p>
         </p:txBody>
@@ -9141,7 +9391,7 @@
               </a:defRPr>
             </a:pPr>
             <a:r>
-              <a:t>Issue #20  |  7 Repositories · 9 Profiles · Compatibility-aware</a:t>
+              <a:t>Issue #20  |  Local RAG · OpenAI Responses · Compatibility-aware</a:t>
             </a:r>
           </a:p>
         </p:txBody>
@@ -9209,7 +9459,7 @@
               </a:defRPr>
             </a:pPr>
             <a:r>
-              <a:t>#41부터 #46까지 코드 분석 범위를 포함해 실행합니다</a:t>
+              <a:t>OpenAI 런타임을 #41·#43·#44로 나눠 구현합니다</a:t>
             </a:r>
           </a:p>
         </p:txBody>
@@ -9720,7 +9970,7 @@
               </a:defRPr>
             </a:pPr>
             <a:r>
-              <a:t>Profiles · API</a:t>
+              <a:t>Provider Profiles</a:t>
             </a:r>
           </a:p>
           <a:p xmlns:a="http://schemas.openxmlformats.org/drawingml/2006/main">
@@ -9736,7 +9986,7 @@
               </a:defRPr>
             </a:pPr>
             <a:r>
-              <a:t>Compatibility DB</a:t>
+              <a:t>15 Tables</a:t>
             </a:r>
           </a:p>
         </p:txBody>
@@ -9936,7 +10186,7 @@
               </a:defRPr>
             </a:pPr>
             <a:r>
-              <a:t>Parser · Symbol</a:t>
+              <a:t>Embeddings</a:t>
             </a:r>
           </a:p>
           <a:p xmlns:a="http://schemas.openxmlformats.org/drawingml/2006/main">
@@ -10044,7 +10294,7 @@
               </a:defRPr>
             </a:pPr>
             <a:r>
-              <a:t>Branch Citation</a:t>
+              <a:t>Responses · Route</a:t>
             </a:r>
           </a:p>
           <a:p xmlns:a="http://schemas.openxmlformats.org/drawingml/2006/main">
@@ -10060,7 +10310,7 @@
               </a:defRPr>
             </a:pPr>
             <a:r>
-              <a:t>Abstention</a:t>
+              <a:t>Citation Validate</a:t>
             </a:r>
           </a:p>
         </p:txBody>
@@ -10135,7 +10385,7 @@
               </a:defRPr>
             </a:pPr>
             <a:r>
-              <a:t>후속 = #45 문서·코드 Activepieces Flow → #46 50개 Golden Set·E2E</a:t>
+              <a:t>후속 = #45 Activepieces Flow → #46 모델·비용·품질·보안 E2E</a:t>
             </a:r>
           </a:p>
         </p:txBody>

</xml_diff>